<commit_message>
fix: update description in tool specs for clarity and remove username reference
</commit_message>
<xml_diff>
--- a/docs/Lab3_Chatbot_vs_ReAct_Agent.pptx
+++ b/docs/Lab3_Chatbot_vs_ReAct_Agent.pptx
@@ -4,6 +4,9 @@
   <p:sldMasterIdLst>
     <p:sldMasterId id="2147483648" r:id="rId1"/>
   </p:sldMasterIdLst>
+  <p:notesMasterIdLst>
+    <p:notesMasterId r:id="rId7"/>
+  </p:notesMasterIdLst>
   <p:sldIdLst>
     <p:sldId id="256" r:id="rId2"/>
     <p:sldId id="257" r:id="rId3"/>
@@ -11,9 +14,6 @@
     <p:sldId id="259" r:id="rId5"/>
     <p:sldId id="260" r:id="rId6"/>
   </p:sldIdLst>
-  <p:notesMasterIdLst>
-    <p:notesMasterId r:id="rId7"/>
-  </p:notesMasterIdLst>
   <p:sldSz cx="12192000" cy="6858000"/>
   <p:notesSz cx="6858000" cy="12192000"/>
   <p:defaultTextStyle>
@@ -108,6 +108,11 @@
       </a:defRPr>
     </a:lvl9pPr>
   </p:defaultTextStyle>
+  <p:extLst>
+    <p:ext uri="{EFAFB233-063F-42B5-8137-9DF3F51BA10A}">
+      <p15:sldGuideLst xmlns:p15="http://schemas.microsoft.com/office/powerpoint/2012/main"/>
+    </p:ext>
+  </p:extLst>
 </p:presentation>
 </file>
 
@@ -133,234 +138,10 @@
           <a:chExt cx="0" cy="0"/>
         </a:xfrm>
       </p:grpSpPr>
-      <p:sp>
-        <p:nvSpPr>
-          <p:cNvPr id="2" name="Header Placeholder 1"/>
-          <p:cNvSpPr>
-            <a:spLocks noGrp="1"/>
-          </p:cNvSpPr>
-          <p:nvPr>
-            <p:ph type="hdr" sz="quarter"/>
-          </p:nvPr>
-        </p:nvSpPr>
-        <p:spPr>
-          <a:xfrm>
-            <a:off x="0" y="0"/>
-            <a:ext cx="2971800" cy="458788"/>
-          </a:xfrm>
-          <a:prstGeom prst="rect">
-            <a:avLst/>
-          </a:prstGeom>
-        </p:spPr>
-        <p:txBody>
-          <a:bodyPr vert="horz" lIns="91440" tIns="45720" rIns="91440" bIns="45720" rtlCol="0"/>
-          <a:lstStyle>
-            <a:lvl1pPr algn="l">
-              <a:defRPr sz="1200"/>
-            </a:lvl1pPr>
-          </a:lstStyle>
-          <a:p>
-            <a:endParaRPr lang="en-US"/>
-          </a:p>
-        </p:txBody>
-      </p:sp>
-      <p:sp>
-        <p:nvSpPr>
-          <p:cNvPr id="3" name="Date Placeholder 2"/>
-          <p:cNvSpPr>
-            <a:spLocks noGrp="1"/>
-          </p:cNvSpPr>
-          <p:nvPr>
-            <p:ph type="dt" idx="1"/>
-          </p:nvPr>
-        </p:nvSpPr>
-        <p:spPr>
-          <a:xfrm>
-            <a:off x="3884613" y="0"/>
-            <a:ext cx="2971800" cy="458788"/>
-          </a:xfrm>
-          <a:prstGeom prst="rect">
-            <a:avLst/>
-          </a:prstGeom>
-        </p:spPr>
-        <p:txBody>
-          <a:bodyPr vert="horz" lIns="91440" tIns="45720" rIns="91440" bIns="45720" rtlCol="0"/>
-          <a:lstStyle>
-            <a:lvl1pPr algn="r">
-              <a:defRPr sz="1200"/>
-            </a:lvl1pPr>
-          </a:lstStyle>
-          <a:p>
-            <a:fld id="{5282F153-3F37-0F45-9E97-73ACFA13230C}" type="datetimeFigureOut">
-              <a:rPr lang="en-US"/>
-              <a:t>7/23/19</a:t>
-            </a:fld>
-            <a:endParaRPr lang="en-US"/>
-          </a:p>
-        </p:txBody>
-      </p:sp>
-      <p:sp>
-        <p:nvSpPr>
-          <p:cNvPr id="4" name="Slide Image Placeholder 3"/>
-          <p:cNvSpPr>
-            <a:spLocks noGrp="1" noRot="1" noChangeAspect="1"/>
-          </p:cNvSpPr>
-          <p:nvPr>
-            <p:ph type="sldImg" idx="2"/>
-          </p:nvPr>
-        </p:nvSpPr>
-        <p:spPr>
-          <a:xfrm>
-            <a:off x="685800" y="1143000"/>
-            <a:ext cx="5486400" cy="3086100"/>
-          </a:xfrm>
-          <a:prstGeom prst="rect">
-            <a:avLst/>
-          </a:prstGeom>
-          <a:noFill/>
-          <a:ln w="12700">
-            <a:solidFill>
-              <a:prstClr val="black"/>
-            </a:solidFill>
-          </a:ln>
-        </p:spPr>
-        <p:txBody>
-          <a:bodyPr vert="horz" lIns="91440" tIns="45720" rIns="91440" bIns="45720" rtlCol="0" anchor="ctr"/>
-          <a:lstStyle/>
-          <a:p>
-            <a:endParaRPr lang="en-US"/>
-          </a:p>
-        </p:txBody>
-      </p:sp>
-      <p:sp>
-        <p:nvSpPr>
-          <p:cNvPr id="5" name="Notes Placeholder 4"/>
-          <p:cNvSpPr>
-            <a:spLocks noGrp="1"/>
-          </p:cNvSpPr>
-          <p:nvPr>
-            <p:ph type="body" sz="quarter" idx="3"/>
-          </p:nvPr>
-        </p:nvSpPr>
-        <p:spPr>
-          <a:xfrm>
-            <a:off x="685800" y="4400550"/>
-            <a:ext cx="5486400" cy="3600450"/>
-          </a:xfrm>
-          <a:prstGeom prst="rect">
-            <a:avLst/>
-          </a:prstGeom>
-        </p:spPr>
-        <p:txBody>
-          <a:bodyPr vert="horz" lIns="91440" tIns="45720" rIns="91440" bIns="45720" rtlCol="0"/>
-          <a:lstStyle/>
-          <a:p>
-            <a:pPr lvl="0"/>
-            <a:r>
-              <a:rPr lang="en-US"/>
-              <a:t>Click to edit Master text styles</a:t>
-            </a:r>
-          </a:p>
-          <a:p>
-            <a:pPr lvl="1"/>
-            <a:r>
-              <a:rPr lang="en-US"/>
-              <a:t>Second level</a:t>
-            </a:r>
-          </a:p>
-          <a:p>
-            <a:pPr lvl="2"/>
-            <a:r>
-              <a:rPr lang="en-US"/>
-              <a:t>Third level</a:t>
-            </a:r>
-          </a:p>
-          <a:p>
-            <a:pPr lvl="3"/>
-            <a:r>
-              <a:rPr lang="en-US"/>
-              <a:t>Fourth level</a:t>
-            </a:r>
-          </a:p>
-          <a:p>
-            <a:pPr lvl="4"/>
-            <a:r>
-              <a:rPr lang="en-US"/>
-              <a:t>Fifth level</a:t>
-            </a:r>
-          </a:p>
-        </p:txBody>
-      </p:sp>
-      <p:sp>
-        <p:nvSpPr>
-          <p:cNvPr id="6" name="Footer Placeholder 5"/>
-          <p:cNvSpPr>
-            <a:spLocks noGrp="1"/>
-          </p:cNvSpPr>
-          <p:nvPr>
-            <p:ph type="ftr" sz="quarter" idx="4"/>
-          </p:nvPr>
-        </p:nvSpPr>
-        <p:spPr>
-          <a:xfrm>
-            <a:off x="0" y="8685213"/>
-            <a:ext cx="2971800" cy="458787"/>
-          </a:xfrm>
-          <a:prstGeom prst="rect">
-            <a:avLst/>
-          </a:prstGeom>
-        </p:spPr>
-        <p:txBody>
-          <a:bodyPr vert="horz" lIns="91440" tIns="45720" rIns="91440" bIns="45720" rtlCol="0" anchor="b"/>
-          <a:lstStyle>
-            <a:lvl1pPr algn="l">
-              <a:defRPr sz="1200"/>
-            </a:lvl1pPr>
-          </a:lstStyle>
-          <a:p>
-            <a:endParaRPr lang="en-US"/>
-          </a:p>
-        </p:txBody>
-      </p:sp>
-      <p:sp>
-        <p:nvSpPr>
-          <p:cNvPr id="7" name="Slide Number Placeholder 6"/>
-          <p:cNvSpPr>
-            <a:spLocks noGrp="1"/>
-          </p:cNvSpPr>
-          <p:nvPr>
-            <p:ph type="sldNum" sz="quarter" idx="5"/>
-          </p:nvPr>
-        </p:nvSpPr>
-        <p:spPr>
-          <a:xfrm>
-            <a:off x="3884613" y="8685213"/>
-            <a:ext cx="2971800" cy="458787"/>
-          </a:xfrm>
-          <a:prstGeom prst="rect">
-            <a:avLst/>
-          </a:prstGeom>
-        </p:spPr>
-        <p:txBody>
-          <a:bodyPr vert="horz" lIns="91440" tIns="45720" rIns="91440" bIns="45720" rtlCol="0" anchor="b"/>
-          <a:lstStyle>
-            <a:lvl1pPr algn="r">
-              <a:defRPr sz="1200"/>
-            </a:lvl1pPr>
-          </a:lstStyle>
-          <a:p>
-            <a:fld id="{CE5E9CC1-C706-0F49-92D6-E571CC5EEA8F}" type="slidenum">
-              <a:rPr lang="en-US"/>
-              <a:t>‹#›</a:t>
-            </a:fld>
-            <a:endParaRPr lang="en-US"/>
-          </a:p>
-        </p:txBody>
-      </p:sp>
     </p:spTree>
     <p:extLst>
       <p:ext uri="{BB962C8B-B14F-4D97-AF65-F5344CB8AC3E}">
-        <p14:creationId xmlns:p14="http://schemas.microsoft.com/office/powerpoint/2010/main" val="1024086991"/>
+        <p14:creationId xmlns:p14="http://schemas.microsoft.com/office/powerpoint/2010/main" val="1595436337"/>
       </p:ext>
     </p:extLst>
   </p:cSld>
@@ -504,10 +285,6 @@
           <a:bodyPr/>
           <a:lstStyle/>
           <a:p>
-            <a:r>
-              <a:rPr lang="en-US" dirty="0"/>
-              <a:t/>
-            </a:r>
             <a:endParaRPr lang="en-US" dirty="0"/>
           </a:p>
         </p:txBody>
@@ -592,10 +369,6 @@
           <a:bodyPr/>
           <a:lstStyle/>
           <a:p>
-            <a:r>
-              <a:rPr lang="en-US" dirty="0"/>
-              <a:t/>
-            </a:r>
             <a:endParaRPr lang="en-US" dirty="0"/>
           </a:p>
         </p:txBody>
@@ -680,10 +453,6 @@
           <a:bodyPr/>
           <a:lstStyle/>
           <a:p>
-            <a:r>
-              <a:rPr lang="en-US" dirty="0"/>
-              <a:t/>
-            </a:r>
             <a:endParaRPr lang="en-US" dirty="0"/>
           </a:p>
         </p:txBody>
@@ -768,10 +537,6 @@
           <a:bodyPr/>
           <a:lstStyle/>
           <a:p>
-            <a:r>
-              <a:rPr lang="en-US" dirty="0"/>
-              <a:t/>
-            </a:r>
             <a:endParaRPr lang="en-US" dirty="0"/>
           </a:p>
         </p:txBody>
@@ -856,10 +621,6 @@
           <a:bodyPr/>
           <a:lstStyle/>
           <a:p>
-            <a:r>
-              <a:rPr lang="en-US" dirty="0"/>
-              <a:t/>
-            </a:r>
             <a:endParaRPr lang="en-US" dirty="0"/>
           </a:p>
         </p:txBody>
@@ -933,6 +694,11 @@
 <file path=ppt/slideMasters/slideMaster1.xml><?xml version="1.0" encoding="utf-8"?>
 <p:sldMaster xmlns:a="http://schemas.openxmlformats.org/drawingml/2006/main" xmlns:r="http://schemas.openxmlformats.org/officeDocument/2006/relationships" xmlns:p="http://schemas.openxmlformats.org/presentationml/2006/main">
   <p:cSld>
+    <p:bg>
+      <p:bgRef idx="1001">
+        <a:schemeClr val="bg1"/>
+      </p:bgRef>
+    </p:bg>
     <p:spTree>
       <p:nvGrpSpPr>
         <p:cNvPr id="1" name=""/>
@@ -1215,6 +981,7 @@
         <a:solidFill>
           <a:srgbClr val="0B2545"/>
         </a:solidFill>
+        <a:effectLst/>
       </p:bgPr>
     </p:bg>
     <p:spTree>
@@ -1296,11 +1063,11 @@
           <a:bodyPr wrap="square" rtlCol="0" anchor="ctr"/>
           <a:lstStyle/>
           <a:p>
-            <a:pPr indent="0" marL="0">
+            <a:pPr marL="0" indent="0">
               <a:buNone/>
             </a:pPr>
             <a:r>
-              <a:rPr lang="en-US" sz="1500" b="1" spc="300" kern="0" dirty="0">
+              <a:rPr lang="en-US" sz="1500" b="1" kern="0" spc="300" dirty="0">
                 <a:solidFill>
                   <a:srgbClr val="02C39A"/>
                 </a:solidFill>
@@ -1335,7 +1102,7 @@
           <a:bodyPr wrap="square" rtlCol="0" anchor="ctr"/>
           <a:lstStyle/>
           <a:p>
-            <a:pPr indent="0" marL="0">
+            <a:pPr marL="0" indent="0">
               <a:buNone/>
             </a:pPr>
             <a:r>
@@ -1374,7 +1141,7 @@
           <a:bodyPr wrap="square" rtlCol="0" anchor="ctr"/>
           <a:lstStyle/>
           <a:p>
-            <a:pPr indent="0" marL="0">
+            <a:pPr marL="0" indent="0">
               <a:lnSpc>
                 <a:spcPct val="110000"/>
               </a:lnSpc>
@@ -1436,9 +1203,6 @@
           <a:bodyPr wrap="square" rtlCol="0" anchor="ctr"/>
           <a:lstStyle/>
           <a:p>
-            <a:pPr indent="0" marL="0">
-              <a:buNone/>
-            </a:pPr>
             <a:r>
               <a:rPr lang="en-US" sz="1400" dirty="0">
                 <a:solidFill>
@@ -1450,9 +1214,6 @@
               </a:rPr>
               <a:t>Team  </a:t>
             </a:r>
-            <a:pPr indent="0" marL="0">
-              <a:buNone/>
-            </a:pPr>
             <a:r>
               <a:rPr lang="en-US" sz="1400" b="1" dirty="0">
                 <a:solidFill>
@@ -1462,11 +1223,8 @@
                 <a:ea typeface="Calibri" pitchFamily="34" charset="-122"/>
                 <a:cs typeface="Calibri" pitchFamily="34" charset="-120"/>
               </a:rPr>
-              <a:t>@hanhvs · @0infinitive0</a:t>
-            </a:r>
-            <a:pPr indent="0" marL="0">
-              <a:buNone/>
-            </a:pPr>
+              <a:t>@hanhvs · @0infinitive0 · @hope304</a:t>
+            </a:r>
             <a:r>
               <a:rPr lang="en-US" sz="1400" dirty="0">
                 <a:solidFill>
@@ -1478,9 +1236,6 @@
               </a:rPr>
               <a:t>      Môi trường  </a:t>
             </a:r>
-            <a:pPr indent="0" marL="0">
-              <a:buNone/>
-            </a:pPr>
             <a:r>
               <a:rPr lang="en-US" sz="1400" b="1" dirty="0">
                 <a:solidFill>
@@ -1517,7 +1272,7 @@
           <a:bodyPr wrap="square" rtlCol="0" anchor="ctr"/>
           <a:lstStyle/>
           <a:p>
-            <a:pPr indent="0" marL="0">
+            <a:pPr marL="0" indent="0">
               <a:buNone/>
             </a:pPr>
             <a:r>
@@ -1551,6 +1306,7 @@
         <a:solidFill>
           <a:srgbClr val="FFFFFF"/>
         </a:solidFill>
+        <a:effectLst/>
       </p:bgPr>
     </p:bg>
     <p:spTree>
@@ -1588,7 +1344,7 @@
           <a:bodyPr wrap="square" rtlCol="0" anchor="ctr"/>
           <a:lstStyle/>
           <a:p>
-            <a:pPr indent="0" marL="0">
+            <a:pPr marL="0" indent="0">
               <a:buNone/>
             </a:pPr>
             <a:r>
@@ -1627,7 +1383,7 @@
           <a:bodyPr wrap="square" rtlCol="0" anchor="ctr"/>
           <a:lstStyle/>
           <a:p>
-            <a:pPr indent="0" marL="0">
+            <a:pPr marL="0" indent="0">
               <a:buNone/>
             </a:pPr>
             <a:r>
@@ -1688,7 +1444,7 @@
           <a:bodyPr wrap="square" rtlCol="0" anchor="ctr"/>
           <a:lstStyle/>
           <a:p>
-            <a:pPr indent="0" marL="0">
+            <a:pPr marL="0" indent="0">
               <a:buNone/>
             </a:pPr>
             <a:r>
@@ -1702,9 +1458,6 @@
               </a:rPr>
               <a:t>Câu hỏi người dùng:  </a:t>
             </a:r>
-            <a:pPr indent="0" marL="0">
-              <a:buNone/>
-            </a:pPr>
             <a:r>
               <a:rPr lang="en-US" sz="1600" i="1" dirty="0">
                 <a:solidFill>
@@ -1744,7 +1497,7 @@
             <a:prstDash val="solid"/>
           </a:ln>
           <a:effectLst>
-            <a:outerShdw sx="100000" sy="100000" kx="0" ky="0" algn="bl" rotWithShape="0" blurRad="101600" dist="38100" dir="8100000">
+            <a:outerShdw blurRad="101600" dist="38100" dir="8100000" algn="bl" rotWithShape="0">
               <a:srgbClr val="000000">
                 <a:alpha val="18000"/>
               </a:srgbClr>
@@ -1774,14 +1527,14 @@
       </p:sp>
       <p:pic>
         <p:nvPicPr>
-          <p:cNvPr id="8" name="Image 0" descr="preencoded.png">    </p:cNvPr>
+          <p:cNvPr id="8" name="Image 0" descr="preencoded.png"/>
           <p:cNvPicPr>
             <a:picLocks noChangeAspect="1"/>
           </p:cNvPicPr>
           <p:nvPr/>
         </p:nvPicPr>
         <p:blipFill>
-          <a:blip r:embed="rId1"/>
+          <a:blip r:embed="rId3"/>
           <a:stretch>
             <a:fillRect/>
           </a:stretch>
@@ -1817,7 +1570,7 @@
           <a:bodyPr wrap="square" rtlCol="0" anchor="ctr"/>
           <a:lstStyle/>
           <a:p>
-            <a:pPr indent="0" marL="0">
+            <a:pPr marL="0" indent="0">
               <a:buNone/>
             </a:pPr>
             <a:r>
@@ -1960,7 +1713,7 @@
           </a:solidFill>
           <a:ln/>
           <a:effectLst>
-            <a:outerShdw sx="100000" sy="100000" kx="0" ky="0" algn="bl" rotWithShape="0" blurRad="101600" dist="38100" dir="8100000">
+            <a:outerShdw blurRad="101600" dist="38100" dir="8100000" algn="bl" rotWithShape="0">
               <a:srgbClr val="000000">
                 <a:alpha val="18000"/>
               </a:srgbClr>
@@ -1990,14 +1743,14 @@
       </p:sp>
       <p:pic>
         <p:nvPicPr>
-          <p:cNvPr id="13" name="Image 1" descr="preencoded.png">    </p:cNvPr>
+          <p:cNvPr id="13" name="Image 1" descr="preencoded.png"/>
           <p:cNvPicPr>
             <a:picLocks noChangeAspect="1"/>
           </p:cNvPicPr>
           <p:nvPr/>
         </p:nvPicPr>
         <p:blipFill>
-          <a:blip r:embed="rId2"/>
+          <a:blip r:embed="rId4"/>
           <a:stretch>
             <a:fillRect/>
           </a:stretch>
@@ -2033,7 +1786,7 @@
           <a:bodyPr wrap="square" rtlCol="0" anchor="ctr"/>
           <a:lstStyle/>
           <a:p>
-            <a:pPr indent="0" marL="0">
+            <a:pPr marL="0" indent="0">
               <a:buNone/>
             </a:pPr>
             <a:r>
@@ -2173,6 +1926,7 @@
         <a:solidFill>
           <a:srgbClr val="FFFFFF"/>
         </a:solidFill>
+        <a:effectLst/>
       </p:bgPr>
     </p:bg>
     <p:spTree>
@@ -2210,7 +1964,7 @@
           <a:bodyPr wrap="square" rtlCol="0" anchor="ctr"/>
           <a:lstStyle/>
           <a:p>
-            <a:pPr indent="0" marL="0">
+            <a:pPr marL="0" indent="0">
               <a:buNone/>
             </a:pPr>
             <a:r>
@@ -2249,7 +2003,7 @@
           <a:bodyPr wrap="square" rtlCol="0" anchor="ctr"/>
           <a:lstStyle/>
           <a:p>
-            <a:pPr indent="0" marL="0">
+            <a:pPr marL="0" indent="0">
               <a:buNone/>
             </a:pPr>
             <a:r>
@@ -2329,331 +2083,7 @@
       </p:sp>
       <p:pic>
         <p:nvPicPr>
-          <p:cNvPr id="7" name="Image 0" descr="preencoded.png">    </p:cNvPr>
-          <p:cNvPicPr>
-            <a:picLocks noChangeAspect="1"/>
-          </p:cNvPicPr>
-          <p:nvPr/>
-        </p:nvPicPr>
-        <p:blipFill>
-          <a:blip r:embed="rId1"/>
-          <a:stretch>
-            <a:fillRect/>
-          </a:stretch>
-        </p:blipFill>
-        <p:spPr>
-          <a:xfrm>
-            <a:off x="1161288" y="1970532"/>
-            <a:ext cx="283464" cy="283464"/>
-          </a:xfrm>
-          <a:prstGeom prst="rect">
-            <a:avLst/>
-          </a:prstGeom>
-        </p:spPr>
-      </p:pic>
-      <p:sp>
-        <p:nvSpPr>
-          <p:cNvPr id="8" name="Text 5"/>
-          <p:cNvSpPr/>
-          <p:nvPr/>
-        </p:nvSpPr>
-        <p:spPr>
-          <a:xfrm>
-            <a:off x="1828800" y="1691640"/>
-            <a:ext cx="2560320" cy="841248"/>
-          </a:xfrm>
-          <a:prstGeom prst="rect">
-            <a:avLst/>
-          </a:prstGeom>
-          <a:noFill/>
-          <a:ln/>
-        </p:spPr>
-        <p:txBody>
-          <a:bodyPr wrap="square" rtlCol="0" anchor="ctr"/>
-          <a:lstStyle/>
-          <a:p>
-            <a:pPr indent="0" marL="0">
-              <a:buNone/>
-            </a:pPr>
-            <a:r>
-              <a:rPr lang="en-US" sz="1700" b="1" dirty="0">
-                <a:solidFill>
-                  <a:srgbClr val="0B2545"/>
-                </a:solidFill>
-                <a:latin typeface="Calibri" pitchFamily="34" charset="0"/>
-                <a:ea typeface="Calibri" pitchFamily="34" charset="-122"/>
-                <a:cs typeface="Calibri" pitchFamily="34" charset="-120"/>
-              </a:rPr>
-              <a:t>Input / Entry</a:t>
-            </a:r>
-            <a:endParaRPr lang="en-US" sz="1700" dirty="0"/>
-          </a:p>
-        </p:txBody>
-      </p:sp>
-      <p:sp>
-        <p:nvSpPr>
-          <p:cNvPr id="9" name="Text 6"/>
-          <p:cNvSpPr/>
-          <p:nvPr/>
-        </p:nvSpPr>
-        <p:spPr>
-          <a:xfrm>
-            <a:off x="4389120" y="1691640"/>
-            <a:ext cx="6858000" cy="841248"/>
-          </a:xfrm>
-          <a:prstGeom prst="rect">
-            <a:avLst/>
-          </a:prstGeom>
-          <a:noFill/>
-          <a:ln/>
-        </p:spPr>
-        <p:txBody>
-          <a:bodyPr wrap="square" rtlCol="0" anchor="ctr"/>
-          <a:lstStyle/>
-          <a:p>
-            <a:pPr indent="0" marL="0">
-              <a:buNone/>
-            </a:pPr>
-            <a:r>
-              <a:rPr lang="en-US" sz="1350" dirty="0">
-                <a:solidFill>
-                  <a:srgbClr val="1E293B"/>
-                </a:solidFill>
-                <a:latin typeface="Consolas" pitchFamily="34" charset="0"/>
-                <a:ea typeface="Consolas" pitchFamily="34" charset="-122"/>
-                <a:cs typeface="Consolas" pitchFamily="34" charset="-120"/>
-              </a:rPr>
-              <a:t>chatbot_baseline.py  ·  ReActAgent.run</a:t>
-            </a:r>
-            <a:endParaRPr lang="en-US" sz="1350" dirty="0"/>
-          </a:p>
-        </p:txBody>
-      </p:sp>
-      <p:sp>
-        <p:nvSpPr>
-          <p:cNvPr id="10" name="Shape 7"/>
-          <p:cNvSpPr/>
-          <p:nvPr/>
-        </p:nvSpPr>
-        <p:spPr>
-          <a:xfrm>
-            <a:off x="731520" y="2642616"/>
-            <a:ext cx="10698480" cy="841248"/>
-          </a:xfrm>
-          <a:prstGeom prst="rect">
-            <a:avLst/>
-          </a:prstGeom>
-          <a:solidFill>
-            <a:srgbClr val="F4F7F8"/>
-          </a:solidFill>
-          <a:ln/>
-        </p:spPr>
-      </p:sp>
-      <p:sp>
-        <p:nvSpPr>
-          <p:cNvPr id="11" name="Shape 8"/>
-          <p:cNvSpPr/>
-          <p:nvPr/>
-        </p:nvSpPr>
-        <p:spPr>
-          <a:xfrm>
-            <a:off x="731520" y="2642616"/>
-            <a:ext cx="91440" cy="841248"/>
-          </a:xfrm>
-          <a:prstGeom prst="rect">
-            <a:avLst/>
-          </a:prstGeom>
-          <a:solidFill>
-            <a:srgbClr val="028090"/>
-          </a:solidFill>
-          <a:ln/>
-        </p:spPr>
-      </p:sp>
-      <p:sp>
-        <p:nvSpPr>
-          <p:cNvPr id="12" name="Shape 9"/>
-          <p:cNvSpPr/>
-          <p:nvPr/>
-        </p:nvSpPr>
-        <p:spPr>
-          <a:xfrm>
-            <a:off x="1051560" y="2811780"/>
-            <a:ext cx="502920" cy="502920"/>
-          </a:xfrm>
-          <a:prstGeom prst="ellipse">
-            <a:avLst/>
-          </a:prstGeom>
-          <a:solidFill>
-            <a:srgbClr val="028090"/>
-          </a:solidFill>
-          <a:ln/>
-        </p:spPr>
-      </p:sp>
-      <p:pic>
-        <p:nvPicPr>
-          <p:cNvPr id="13" name="Image 1" descr="preencoded.png">    </p:cNvPr>
-          <p:cNvPicPr>
-            <a:picLocks noChangeAspect="1"/>
-          </p:cNvPicPr>
-          <p:nvPr/>
-        </p:nvPicPr>
-        <p:blipFill>
-          <a:blip r:embed="rId2"/>
-          <a:stretch>
-            <a:fillRect/>
-          </a:stretch>
-        </p:blipFill>
-        <p:spPr>
-          <a:xfrm>
-            <a:off x="1161288" y="2921508"/>
-            <a:ext cx="283464" cy="283464"/>
-          </a:xfrm>
-          <a:prstGeom prst="rect">
-            <a:avLst/>
-          </a:prstGeom>
-        </p:spPr>
-      </p:pic>
-      <p:sp>
-        <p:nvSpPr>
-          <p:cNvPr id="14" name="Text 10"/>
-          <p:cNvSpPr/>
-          <p:nvPr/>
-        </p:nvSpPr>
-        <p:spPr>
-          <a:xfrm>
-            <a:off x="1828800" y="2642616"/>
-            <a:ext cx="2560320" cy="841248"/>
-          </a:xfrm>
-          <a:prstGeom prst="rect">
-            <a:avLst/>
-          </a:prstGeom>
-          <a:noFill/>
-          <a:ln/>
-        </p:spPr>
-        <p:txBody>
-          <a:bodyPr wrap="square" rtlCol="0" anchor="ctr"/>
-          <a:lstStyle/>
-          <a:p>
-            <a:pPr indent="0" marL="0">
-              <a:buNone/>
-            </a:pPr>
-            <a:r>
-              <a:rPr lang="en-US" sz="1700" b="1" dirty="0">
-                <a:solidFill>
-                  <a:srgbClr val="0B2545"/>
-                </a:solidFill>
-                <a:latin typeface="Calibri" pitchFamily="34" charset="0"/>
-                <a:ea typeface="Calibri" pitchFamily="34" charset="-122"/>
-                <a:cs typeface="Calibri" pitchFamily="34" charset="-120"/>
-              </a:rPr>
-              <a:t>LLM Core</a:t>
-            </a:r>
-            <a:endParaRPr lang="en-US" sz="1700" dirty="0"/>
-          </a:p>
-        </p:txBody>
-      </p:sp>
-      <p:sp>
-        <p:nvSpPr>
-          <p:cNvPr id="15" name="Text 11"/>
-          <p:cNvSpPr/>
-          <p:nvPr/>
-        </p:nvSpPr>
-        <p:spPr>
-          <a:xfrm>
-            <a:off x="4389120" y="2642616"/>
-            <a:ext cx="6858000" cy="841248"/>
-          </a:xfrm>
-          <a:prstGeom prst="rect">
-            <a:avLst/>
-          </a:prstGeom>
-          <a:noFill/>
-          <a:ln/>
-        </p:spPr>
-        <p:txBody>
-          <a:bodyPr wrap="square" rtlCol="0" anchor="ctr"/>
-          <a:lstStyle/>
-          <a:p>
-            <a:pPr indent="0" marL="0">
-              <a:buNone/>
-            </a:pPr>
-            <a:r>
-              <a:rPr lang="en-US" sz="1350" dirty="0">
-                <a:solidFill>
-                  <a:srgbClr val="1E293B"/>
-                </a:solidFill>
-                <a:latin typeface="Consolas" pitchFamily="34" charset="0"/>
-                <a:ea typeface="Consolas" pitchFamily="34" charset="-122"/>
-                <a:cs typeface="Consolas" pitchFamily="34" charset="-120"/>
-              </a:rPr>
-              <a:t>get_llm_from_env() → OpenAI · Gemini · Local (Phi-3 GGUF)</a:t>
-            </a:r>
-            <a:endParaRPr lang="en-US" sz="1350" dirty="0"/>
-          </a:p>
-        </p:txBody>
-      </p:sp>
-      <p:sp>
-        <p:nvSpPr>
-          <p:cNvPr id="16" name="Shape 12"/>
-          <p:cNvSpPr/>
-          <p:nvPr/>
-        </p:nvSpPr>
-        <p:spPr>
-          <a:xfrm>
-            <a:off x="731520" y="3593592"/>
-            <a:ext cx="10698480" cy="841248"/>
-          </a:xfrm>
-          <a:prstGeom prst="rect">
-            <a:avLst/>
-          </a:prstGeom>
-          <a:solidFill>
-            <a:srgbClr val="F4F7F8"/>
-          </a:solidFill>
-          <a:ln/>
-        </p:spPr>
-      </p:sp>
-      <p:sp>
-        <p:nvSpPr>
-          <p:cNvPr id="17" name="Shape 13"/>
-          <p:cNvSpPr/>
-          <p:nvPr/>
-        </p:nvSpPr>
-        <p:spPr>
-          <a:xfrm>
-            <a:off x="731520" y="3593592"/>
-            <a:ext cx="91440" cy="841248"/>
-          </a:xfrm>
-          <a:prstGeom prst="rect">
-            <a:avLst/>
-          </a:prstGeom>
-          <a:solidFill>
-            <a:srgbClr val="00A896"/>
-          </a:solidFill>
-          <a:ln/>
-        </p:spPr>
-      </p:sp>
-      <p:sp>
-        <p:nvSpPr>
-          <p:cNvPr id="18" name="Shape 14"/>
-          <p:cNvSpPr/>
-          <p:nvPr/>
-        </p:nvSpPr>
-        <p:spPr>
-          <a:xfrm>
-            <a:off x="1051560" y="3762756"/>
-            <a:ext cx="502920" cy="502920"/>
-          </a:xfrm>
-          <a:prstGeom prst="ellipse">
-            <a:avLst/>
-          </a:prstGeom>
-          <a:solidFill>
-            <a:srgbClr val="00A896"/>
-          </a:solidFill>
-          <a:ln/>
-        </p:spPr>
-      </p:sp>
-      <p:pic>
-        <p:nvPicPr>
-          <p:cNvPr id="19" name="Image 2" descr="preencoded.png">    </p:cNvPr>
+          <p:cNvPr id="7" name="Image 0" descr="preencoded.png"/>
           <p:cNvPicPr>
             <a:picLocks noChangeAspect="1"/>
           </p:cNvPicPr>
@@ -2667,7 +2097,7 @@
         </p:blipFill>
         <p:spPr>
           <a:xfrm>
-            <a:off x="1161288" y="3872484"/>
+            <a:off x="1161288" y="1970532"/>
             <a:ext cx="283464" cy="283464"/>
           </a:xfrm>
           <a:prstGeom prst="rect">
@@ -2677,13 +2107,13 @@
       </p:pic>
       <p:sp>
         <p:nvSpPr>
-          <p:cNvPr id="20" name="Text 15"/>
-          <p:cNvSpPr/>
-          <p:nvPr/>
-        </p:nvSpPr>
-        <p:spPr>
-          <a:xfrm>
-            <a:off x="1828800" y="3593592"/>
+          <p:cNvPr id="8" name="Text 5"/>
+          <p:cNvSpPr/>
+          <p:nvPr/>
+        </p:nvSpPr>
+        <p:spPr>
+          <a:xfrm>
+            <a:off x="1828800" y="1691640"/>
             <a:ext cx="2560320" cy="841248"/>
           </a:xfrm>
           <a:prstGeom prst="rect">
@@ -2696,7 +2126,7 @@
           <a:bodyPr wrap="square" rtlCol="0" anchor="ctr"/>
           <a:lstStyle/>
           <a:p>
-            <a:pPr indent="0" marL="0">
+            <a:pPr marL="0" indent="0">
               <a:buNone/>
             </a:pPr>
             <a:r>
@@ -2708,7 +2138,7 @@
                 <a:ea typeface="Calibri" pitchFamily="34" charset="-122"/>
                 <a:cs typeface="Calibri" pitchFamily="34" charset="-120"/>
               </a:rPr>
-              <a:t>Agent Loop</a:t>
+              <a:t>Input / Entry</a:t>
             </a:r>
             <a:endParaRPr lang="en-US" sz="1700" dirty="0"/>
           </a:p>
@@ -2716,13 +2146,13 @@
       </p:sp>
       <p:sp>
         <p:nvSpPr>
-          <p:cNvPr id="21" name="Text 16"/>
-          <p:cNvSpPr/>
-          <p:nvPr/>
-        </p:nvSpPr>
-        <p:spPr>
-          <a:xfrm>
-            <a:off x="4389120" y="3593592"/>
+          <p:cNvPr id="9" name="Text 6"/>
+          <p:cNvSpPr/>
+          <p:nvPr/>
+        </p:nvSpPr>
+        <p:spPr>
+          <a:xfrm>
+            <a:off x="4389120" y="1691640"/>
             <a:ext cx="6858000" cy="841248"/>
           </a:xfrm>
           <a:prstGeom prst="rect">
@@ -2735,7 +2165,7 @@
           <a:bodyPr wrap="square" rtlCol="0" anchor="ctr"/>
           <a:lstStyle/>
           <a:p>
-            <a:pPr indent="0" marL="0">
+            <a:pPr marL="0" indent="0">
               <a:buNone/>
             </a:pPr>
             <a:r>
@@ -2747,7 +2177,7 @@
                 <a:ea typeface="Consolas" pitchFamily="34" charset="-122"/>
                 <a:cs typeface="Consolas" pitchFamily="34" charset="-120"/>
               </a:rPr>
-              <a:t>action_parser (regex+ast) → _execute_tool → dispatch</a:t>
+              <a:t>chatbot_baseline.py  ·  ReActAgent.run</a:t>
             </a:r>
             <a:endParaRPr lang="en-US" sz="1350" dirty="0"/>
           </a:p>
@@ -2755,13 +2185,13 @@
       </p:sp>
       <p:sp>
         <p:nvSpPr>
-          <p:cNvPr id="22" name="Shape 17"/>
-          <p:cNvSpPr/>
-          <p:nvPr/>
-        </p:nvSpPr>
-        <p:spPr>
-          <a:xfrm>
-            <a:off x="731520" y="4544568"/>
+          <p:cNvPr id="10" name="Shape 7"/>
+          <p:cNvSpPr/>
+          <p:nvPr/>
+        </p:nvSpPr>
+        <p:spPr>
+          <a:xfrm>
+            <a:off x="731520" y="2642616"/>
             <a:ext cx="10698480" cy="841248"/>
           </a:xfrm>
           <a:prstGeom prst="rect">
@@ -2775,47 +2205,47 @@
       </p:sp>
       <p:sp>
         <p:nvSpPr>
-          <p:cNvPr id="23" name="Shape 18"/>
-          <p:cNvSpPr/>
-          <p:nvPr/>
-        </p:nvSpPr>
-        <p:spPr>
-          <a:xfrm>
-            <a:off x="731520" y="4544568"/>
+          <p:cNvPr id="11" name="Shape 8"/>
+          <p:cNvSpPr/>
+          <p:nvPr/>
+        </p:nvSpPr>
+        <p:spPr>
+          <a:xfrm>
+            <a:off x="731520" y="2642616"/>
             <a:ext cx="91440" cy="841248"/>
           </a:xfrm>
           <a:prstGeom prst="rect">
             <a:avLst/>
           </a:prstGeom>
           <a:solidFill>
-            <a:srgbClr val="02C39A"/>
-          </a:solidFill>
-          <a:ln/>
-        </p:spPr>
-      </p:sp>
-      <p:sp>
-        <p:nvSpPr>
-          <p:cNvPr id="24" name="Shape 19"/>
-          <p:cNvSpPr/>
-          <p:nvPr/>
-        </p:nvSpPr>
-        <p:spPr>
-          <a:xfrm>
-            <a:off x="1051560" y="4713732"/>
+            <a:srgbClr val="028090"/>
+          </a:solidFill>
+          <a:ln/>
+        </p:spPr>
+      </p:sp>
+      <p:sp>
+        <p:nvSpPr>
+          <p:cNvPr id="12" name="Shape 9"/>
+          <p:cNvSpPr/>
+          <p:nvPr/>
+        </p:nvSpPr>
+        <p:spPr>
+          <a:xfrm>
+            <a:off x="1051560" y="2811780"/>
             <a:ext cx="502920" cy="502920"/>
           </a:xfrm>
           <a:prstGeom prst="ellipse">
             <a:avLst/>
           </a:prstGeom>
           <a:solidFill>
-            <a:srgbClr val="02C39A"/>
+            <a:srgbClr val="028090"/>
           </a:solidFill>
           <a:ln/>
         </p:spPr>
       </p:sp>
       <p:pic>
         <p:nvPicPr>
-          <p:cNvPr id="25" name="Image 3" descr="preencoded.png">    </p:cNvPr>
+          <p:cNvPr id="13" name="Image 1" descr="preencoded.png"/>
           <p:cNvPicPr>
             <a:picLocks noChangeAspect="1"/>
           </p:cNvPicPr>
@@ -2829,7 +2259,7 @@
         </p:blipFill>
         <p:spPr>
           <a:xfrm>
-            <a:off x="1161288" y="4823460"/>
+            <a:off x="1161288" y="2921508"/>
             <a:ext cx="283464" cy="283464"/>
           </a:xfrm>
           <a:prstGeom prst="rect">
@@ -2839,13 +2269,13 @@
       </p:pic>
       <p:sp>
         <p:nvSpPr>
-          <p:cNvPr id="26" name="Text 20"/>
-          <p:cNvSpPr/>
-          <p:nvPr/>
-        </p:nvSpPr>
-        <p:spPr>
-          <a:xfrm>
-            <a:off x="1828800" y="4544568"/>
+          <p:cNvPr id="14" name="Text 10"/>
+          <p:cNvSpPr/>
+          <p:nvPr/>
+        </p:nvSpPr>
+        <p:spPr>
+          <a:xfrm>
+            <a:off x="1828800" y="2642616"/>
             <a:ext cx="2560320" cy="841248"/>
           </a:xfrm>
           <a:prstGeom prst="rect">
@@ -2858,7 +2288,7 @@
           <a:bodyPr wrap="square" rtlCol="0" anchor="ctr"/>
           <a:lstStyle/>
           <a:p>
-            <a:pPr indent="0" marL="0">
+            <a:pPr marL="0" indent="0">
               <a:buNone/>
             </a:pPr>
             <a:r>
@@ -2870,7 +2300,7 @@
                 <a:ea typeface="Calibri" pitchFamily="34" charset="-122"/>
                 <a:cs typeface="Calibri" pitchFamily="34" charset="-120"/>
               </a:rPr>
-              <a:t>Tools</a:t>
+              <a:t>LLM Core</a:t>
             </a:r>
             <a:endParaRPr lang="en-US" sz="1700" dirty="0"/>
           </a:p>
@@ -2878,13 +2308,13 @@
       </p:sp>
       <p:sp>
         <p:nvSpPr>
-          <p:cNvPr id="27" name="Text 21"/>
-          <p:cNvSpPr/>
-          <p:nvPr/>
-        </p:nvSpPr>
-        <p:spPr>
-          <a:xfrm>
-            <a:off x="4389120" y="4544568"/>
+          <p:cNvPr id="15" name="Text 11"/>
+          <p:cNvSpPr/>
+          <p:nvPr/>
+        </p:nvSpPr>
+        <p:spPr>
+          <a:xfrm>
+            <a:off x="4389120" y="2642616"/>
             <a:ext cx="6858000" cy="841248"/>
           </a:xfrm>
           <a:prstGeom prst="rect">
@@ -2897,7 +2327,7 @@
           <a:bodyPr wrap="square" rtlCol="0" anchor="ctr"/>
           <a:lstStyle/>
           <a:p>
-            <a:pPr indent="0" marL="0">
+            <a:pPr marL="0" indent="0">
               <a:buNone/>
             </a:pPr>
             <a:r>
@@ -2909,7 +2339,7 @@
                 <a:ea typeface="Consolas" pitchFamily="34" charset="-122"/>
                 <a:cs typeface="Consolas" pitchFamily="34" charset="-120"/>
               </a:rPr>
-              <a:t>product_catalog · condition_scoring · listings_mock · web_search</a:t>
+              <a:t>get_llm_from_env() → OpenAI · Gemini · Local (Phi-3 GGUF)</a:t>
             </a:r>
             <a:endParaRPr lang="en-US" sz="1350" dirty="0"/>
           </a:p>
@@ -2917,13 +2347,13 @@
       </p:sp>
       <p:sp>
         <p:nvSpPr>
-          <p:cNvPr id="28" name="Shape 22"/>
-          <p:cNvSpPr/>
-          <p:nvPr/>
-        </p:nvSpPr>
-        <p:spPr>
-          <a:xfrm>
-            <a:off x="731520" y="5495544"/>
+          <p:cNvPr id="16" name="Shape 12"/>
+          <p:cNvSpPr/>
+          <p:nvPr/>
+        </p:nvSpPr>
+        <p:spPr>
+          <a:xfrm>
+            <a:off x="731520" y="3593592"/>
             <a:ext cx="10698480" cy="841248"/>
           </a:xfrm>
           <a:prstGeom prst="rect">
@@ -2937,47 +2367,47 @@
       </p:sp>
       <p:sp>
         <p:nvSpPr>
-          <p:cNvPr id="29" name="Shape 23"/>
-          <p:cNvSpPr/>
-          <p:nvPr/>
-        </p:nvSpPr>
-        <p:spPr>
-          <a:xfrm>
-            <a:off x="731520" y="5495544"/>
+          <p:cNvPr id="17" name="Shape 13"/>
+          <p:cNvSpPr/>
+          <p:nvPr/>
+        </p:nvSpPr>
+        <p:spPr>
+          <a:xfrm>
+            <a:off x="731520" y="3593592"/>
             <a:ext cx="91440" cy="841248"/>
           </a:xfrm>
           <a:prstGeom prst="rect">
             <a:avLst/>
           </a:prstGeom>
           <a:solidFill>
-            <a:srgbClr val="0B2545"/>
-          </a:solidFill>
-          <a:ln/>
-        </p:spPr>
-      </p:sp>
-      <p:sp>
-        <p:nvSpPr>
-          <p:cNvPr id="30" name="Shape 24"/>
-          <p:cNvSpPr/>
-          <p:nvPr/>
-        </p:nvSpPr>
-        <p:spPr>
-          <a:xfrm>
-            <a:off x="1051560" y="5664708"/>
+            <a:srgbClr val="00A896"/>
+          </a:solidFill>
+          <a:ln/>
+        </p:spPr>
+      </p:sp>
+      <p:sp>
+        <p:nvSpPr>
+          <p:cNvPr id="18" name="Shape 14"/>
+          <p:cNvSpPr/>
+          <p:nvPr/>
+        </p:nvSpPr>
+        <p:spPr>
+          <a:xfrm>
+            <a:off x="1051560" y="3762756"/>
             <a:ext cx="502920" cy="502920"/>
           </a:xfrm>
           <a:prstGeom prst="ellipse">
             <a:avLst/>
           </a:prstGeom>
           <a:solidFill>
-            <a:srgbClr val="0B2545"/>
+            <a:srgbClr val="00A896"/>
           </a:solidFill>
           <a:ln/>
         </p:spPr>
       </p:sp>
       <p:pic>
         <p:nvPicPr>
-          <p:cNvPr id="31" name="Image 4" descr="preencoded.png">    </p:cNvPr>
+          <p:cNvPr id="19" name="Image 2" descr="preencoded.png"/>
           <p:cNvPicPr>
             <a:picLocks noChangeAspect="1"/>
           </p:cNvPicPr>
@@ -2991,7 +2421,7 @@
         </p:blipFill>
         <p:spPr>
           <a:xfrm>
-            <a:off x="1161288" y="5774436"/>
+            <a:off x="1161288" y="3872484"/>
             <a:ext cx="283464" cy="283464"/>
           </a:xfrm>
           <a:prstGeom prst="rect">
@@ -3001,13 +2431,13 @@
       </p:pic>
       <p:sp>
         <p:nvSpPr>
-          <p:cNvPr id="32" name="Text 25"/>
-          <p:cNvSpPr/>
-          <p:nvPr/>
-        </p:nvSpPr>
-        <p:spPr>
-          <a:xfrm>
-            <a:off x="1828800" y="5495544"/>
+          <p:cNvPr id="20" name="Text 15"/>
+          <p:cNvSpPr/>
+          <p:nvPr/>
+        </p:nvSpPr>
+        <p:spPr>
+          <a:xfrm>
+            <a:off x="1828800" y="3593592"/>
             <a:ext cx="2560320" cy="841248"/>
           </a:xfrm>
           <a:prstGeom prst="rect">
@@ -3020,7 +2450,7 @@
           <a:bodyPr wrap="square" rtlCol="0" anchor="ctr"/>
           <a:lstStyle/>
           <a:p>
-            <a:pPr indent="0" marL="0">
+            <a:pPr marL="0" indent="0">
               <a:buNone/>
             </a:pPr>
             <a:r>
@@ -3032,6 +2462,330 @@
                 <a:ea typeface="Calibri" pitchFamily="34" charset="-122"/>
                 <a:cs typeface="Calibri" pitchFamily="34" charset="-120"/>
               </a:rPr>
+              <a:t>Agent Loop</a:t>
+            </a:r>
+            <a:endParaRPr lang="en-US" sz="1700" dirty="0"/>
+          </a:p>
+        </p:txBody>
+      </p:sp>
+      <p:sp>
+        <p:nvSpPr>
+          <p:cNvPr id="21" name="Text 16"/>
+          <p:cNvSpPr/>
+          <p:nvPr/>
+        </p:nvSpPr>
+        <p:spPr>
+          <a:xfrm>
+            <a:off x="4389120" y="3593592"/>
+            <a:ext cx="6858000" cy="841248"/>
+          </a:xfrm>
+          <a:prstGeom prst="rect">
+            <a:avLst/>
+          </a:prstGeom>
+          <a:noFill/>
+          <a:ln/>
+        </p:spPr>
+        <p:txBody>
+          <a:bodyPr wrap="square" rtlCol="0" anchor="ctr"/>
+          <a:lstStyle/>
+          <a:p>
+            <a:pPr marL="0" indent="0">
+              <a:buNone/>
+            </a:pPr>
+            <a:r>
+              <a:rPr lang="en-US" sz="1350" dirty="0">
+                <a:solidFill>
+                  <a:srgbClr val="1E293B"/>
+                </a:solidFill>
+                <a:latin typeface="Consolas" pitchFamily="34" charset="0"/>
+                <a:ea typeface="Consolas" pitchFamily="34" charset="-122"/>
+                <a:cs typeface="Consolas" pitchFamily="34" charset="-120"/>
+              </a:rPr>
+              <a:t>action_parser (regex+ast) → _execute_tool → dispatch</a:t>
+            </a:r>
+            <a:endParaRPr lang="en-US" sz="1350" dirty="0"/>
+          </a:p>
+        </p:txBody>
+      </p:sp>
+      <p:sp>
+        <p:nvSpPr>
+          <p:cNvPr id="22" name="Shape 17"/>
+          <p:cNvSpPr/>
+          <p:nvPr/>
+        </p:nvSpPr>
+        <p:spPr>
+          <a:xfrm>
+            <a:off x="731520" y="4544568"/>
+            <a:ext cx="10698480" cy="841248"/>
+          </a:xfrm>
+          <a:prstGeom prst="rect">
+            <a:avLst/>
+          </a:prstGeom>
+          <a:solidFill>
+            <a:srgbClr val="F4F7F8"/>
+          </a:solidFill>
+          <a:ln/>
+        </p:spPr>
+      </p:sp>
+      <p:sp>
+        <p:nvSpPr>
+          <p:cNvPr id="23" name="Shape 18"/>
+          <p:cNvSpPr/>
+          <p:nvPr/>
+        </p:nvSpPr>
+        <p:spPr>
+          <a:xfrm>
+            <a:off x="731520" y="4544568"/>
+            <a:ext cx="91440" cy="841248"/>
+          </a:xfrm>
+          <a:prstGeom prst="rect">
+            <a:avLst/>
+          </a:prstGeom>
+          <a:solidFill>
+            <a:srgbClr val="02C39A"/>
+          </a:solidFill>
+          <a:ln/>
+        </p:spPr>
+      </p:sp>
+      <p:sp>
+        <p:nvSpPr>
+          <p:cNvPr id="24" name="Shape 19"/>
+          <p:cNvSpPr/>
+          <p:nvPr/>
+        </p:nvSpPr>
+        <p:spPr>
+          <a:xfrm>
+            <a:off x="1051560" y="4713732"/>
+            <a:ext cx="502920" cy="502920"/>
+          </a:xfrm>
+          <a:prstGeom prst="ellipse">
+            <a:avLst/>
+          </a:prstGeom>
+          <a:solidFill>
+            <a:srgbClr val="02C39A"/>
+          </a:solidFill>
+          <a:ln/>
+        </p:spPr>
+      </p:sp>
+      <p:pic>
+        <p:nvPicPr>
+          <p:cNvPr id="25" name="Image 3" descr="preencoded.png"/>
+          <p:cNvPicPr>
+            <a:picLocks noChangeAspect="1"/>
+          </p:cNvPicPr>
+          <p:nvPr/>
+        </p:nvPicPr>
+        <p:blipFill>
+          <a:blip r:embed="rId6"/>
+          <a:stretch>
+            <a:fillRect/>
+          </a:stretch>
+        </p:blipFill>
+        <p:spPr>
+          <a:xfrm>
+            <a:off x="1161288" y="4823460"/>
+            <a:ext cx="283464" cy="283464"/>
+          </a:xfrm>
+          <a:prstGeom prst="rect">
+            <a:avLst/>
+          </a:prstGeom>
+        </p:spPr>
+      </p:pic>
+      <p:sp>
+        <p:nvSpPr>
+          <p:cNvPr id="26" name="Text 20"/>
+          <p:cNvSpPr/>
+          <p:nvPr/>
+        </p:nvSpPr>
+        <p:spPr>
+          <a:xfrm>
+            <a:off x="1828800" y="4544568"/>
+            <a:ext cx="2560320" cy="841248"/>
+          </a:xfrm>
+          <a:prstGeom prst="rect">
+            <a:avLst/>
+          </a:prstGeom>
+          <a:noFill/>
+          <a:ln/>
+        </p:spPr>
+        <p:txBody>
+          <a:bodyPr wrap="square" rtlCol="0" anchor="ctr"/>
+          <a:lstStyle/>
+          <a:p>
+            <a:pPr marL="0" indent="0">
+              <a:buNone/>
+            </a:pPr>
+            <a:r>
+              <a:rPr lang="en-US" sz="1700" b="1" dirty="0">
+                <a:solidFill>
+                  <a:srgbClr val="0B2545"/>
+                </a:solidFill>
+                <a:latin typeface="Calibri" pitchFamily="34" charset="0"/>
+                <a:ea typeface="Calibri" pitchFamily="34" charset="-122"/>
+                <a:cs typeface="Calibri" pitchFamily="34" charset="-120"/>
+              </a:rPr>
+              <a:t>Tools</a:t>
+            </a:r>
+            <a:endParaRPr lang="en-US" sz="1700" dirty="0"/>
+          </a:p>
+        </p:txBody>
+      </p:sp>
+      <p:sp>
+        <p:nvSpPr>
+          <p:cNvPr id="27" name="Text 21"/>
+          <p:cNvSpPr/>
+          <p:nvPr/>
+        </p:nvSpPr>
+        <p:spPr>
+          <a:xfrm>
+            <a:off x="4389120" y="4544568"/>
+            <a:ext cx="6858000" cy="841248"/>
+          </a:xfrm>
+          <a:prstGeom prst="rect">
+            <a:avLst/>
+          </a:prstGeom>
+          <a:noFill/>
+          <a:ln/>
+        </p:spPr>
+        <p:txBody>
+          <a:bodyPr wrap="square" rtlCol="0" anchor="ctr"/>
+          <a:lstStyle/>
+          <a:p>
+            <a:pPr marL="0" indent="0">
+              <a:buNone/>
+            </a:pPr>
+            <a:r>
+              <a:rPr lang="en-US" sz="1350" dirty="0">
+                <a:solidFill>
+                  <a:srgbClr val="1E293B"/>
+                </a:solidFill>
+                <a:latin typeface="Consolas" pitchFamily="34" charset="0"/>
+                <a:ea typeface="Consolas" pitchFamily="34" charset="-122"/>
+                <a:cs typeface="Consolas" pitchFamily="34" charset="-120"/>
+              </a:rPr>
+              <a:t>product_catalog · condition_scoring · listings_mock · web_search</a:t>
+            </a:r>
+            <a:endParaRPr lang="en-US" sz="1350" dirty="0"/>
+          </a:p>
+        </p:txBody>
+      </p:sp>
+      <p:sp>
+        <p:nvSpPr>
+          <p:cNvPr id="28" name="Shape 22"/>
+          <p:cNvSpPr/>
+          <p:nvPr/>
+        </p:nvSpPr>
+        <p:spPr>
+          <a:xfrm>
+            <a:off x="731520" y="5495544"/>
+            <a:ext cx="10698480" cy="841248"/>
+          </a:xfrm>
+          <a:prstGeom prst="rect">
+            <a:avLst/>
+          </a:prstGeom>
+          <a:solidFill>
+            <a:srgbClr val="F4F7F8"/>
+          </a:solidFill>
+          <a:ln/>
+        </p:spPr>
+      </p:sp>
+      <p:sp>
+        <p:nvSpPr>
+          <p:cNvPr id="29" name="Shape 23"/>
+          <p:cNvSpPr/>
+          <p:nvPr/>
+        </p:nvSpPr>
+        <p:spPr>
+          <a:xfrm>
+            <a:off x="731520" y="5495544"/>
+            <a:ext cx="91440" cy="841248"/>
+          </a:xfrm>
+          <a:prstGeom prst="rect">
+            <a:avLst/>
+          </a:prstGeom>
+          <a:solidFill>
+            <a:srgbClr val="0B2545"/>
+          </a:solidFill>
+          <a:ln/>
+        </p:spPr>
+      </p:sp>
+      <p:sp>
+        <p:nvSpPr>
+          <p:cNvPr id="30" name="Shape 24"/>
+          <p:cNvSpPr/>
+          <p:nvPr/>
+        </p:nvSpPr>
+        <p:spPr>
+          <a:xfrm>
+            <a:off x="1051560" y="5664708"/>
+            <a:ext cx="502920" cy="502920"/>
+          </a:xfrm>
+          <a:prstGeom prst="ellipse">
+            <a:avLst/>
+          </a:prstGeom>
+          <a:solidFill>
+            <a:srgbClr val="0B2545"/>
+          </a:solidFill>
+          <a:ln/>
+        </p:spPr>
+      </p:sp>
+      <p:pic>
+        <p:nvPicPr>
+          <p:cNvPr id="31" name="Image 4" descr="preencoded.png"/>
+          <p:cNvPicPr>
+            <a:picLocks noChangeAspect="1"/>
+          </p:cNvPicPr>
+          <p:nvPr/>
+        </p:nvPicPr>
+        <p:blipFill>
+          <a:blip r:embed="rId7"/>
+          <a:stretch>
+            <a:fillRect/>
+          </a:stretch>
+        </p:blipFill>
+        <p:spPr>
+          <a:xfrm>
+            <a:off x="1161288" y="5774436"/>
+            <a:ext cx="283464" cy="283464"/>
+          </a:xfrm>
+          <a:prstGeom prst="rect">
+            <a:avLst/>
+          </a:prstGeom>
+        </p:spPr>
+      </p:pic>
+      <p:sp>
+        <p:nvSpPr>
+          <p:cNvPr id="32" name="Text 25"/>
+          <p:cNvSpPr/>
+          <p:nvPr/>
+        </p:nvSpPr>
+        <p:spPr>
+          <a:xfrm>
+            <a:off x="1828800" y="5495544"/>
+            <a:ext cx="2560320" cy="841248"/>
+          </a:xfrm>
+          <a:prstGeom prst="rect">
+            <a:avLst/>
+          </a:prstGeom>
+          <a:noFill/>
+          <a:ln/>
+        </p:spPr>
+        <p:txBody>
+          <a:bodyPr wrap="square" rtlCol="0" anchor="ctr"/>
+          <a:lstStyle/>
+          <a:p>
+            <a:pPr marL="0" indent="0">
+              <a:buNone/>
+            </a:pPr>
+            <a:r>
+              <a:rPr lang="en-US" sz="1700" b="1" dirty="0">
+                <a:solidFill>
+                  <a:srgbClr val="0B2545"/>
+                </a:solidFill>
+                <a:latin typeface="Calibri" pitchFamily="34" charset="0"/>
+                <a:ea typeface="Calibri" pitchFamily="34" charset="-122"/>
+                <a:cs typeface="Calibri" pitchFamily="34" charset="-120"/>
+              </a:rPr>
               <a:t>Observability</a:t>
             </a:r>
             <a:endParaRPr lang="en-US" sz="1700" dirty="0"/>
@@ -3059,7 +2813,7 @@
           <a:bodyPr wrap="square" rtlCol="0" anchor="ctr"/>
           <a:lstStyle/>
           <a:p>
-            <a:pPr indent="0" marL="0">
+            <a:pPr marL="0" indent="0">
               <a:buNone/>
             </a:pPr>
             <a:r>
@@ -3093,6 +2847,7 @@
         <a:solidFill>
           <a:srgbClr val="0B2545"/>
         </a:solidFill>
+        <a:effectLst/>
       </p:bgPr>
     </p:bg>
     <p:spTree>
@@ -3130,7 +2885,7 @@
           <a:bodyPr wrap="square" rtlCol="0" anchor="ctr"/>
           <a:lstStyle/>
           <a:p>
-            <a:pPr indent="0" marL="0">
+            <a:pPr marL="0" indent="0">
               <a:buNone/>
             </a:pPr>
             <a:r>
@@ -3169,7 +2924,7 @@
           <a:bodyPr wrap="square" rtlCol="0" anchor="ctr"/>
           <a:lstStyle/>
           <a:p>
-            <a:pPr indent="0" marL="0">
+            <a:pPr marL="0" indent="0">
               <a:buNone/>
             </a:pPr>
             <a:r>
@@ -3183,9 +2938,6 @@
               </a:rPr>
               <a:t>Thought → Action → Observation</a:t>
             </a:r>
-            <a:pPr indent="0" marL="0">
-              <a:buNone/>
-            </a:pPr>
             <a:r>
               <a:rPr lang="en-US" sz="1500" dirty="0">
                 <a:solidFill>
@@ -3222,7 +2974,7 @@
           </a:solidFill>
           <a:ln/>
           <a:effectLst>
-            <a:outerShdw sx="100000" sy="100000" kx="0" ky="0" algn="bl" rotWithShape="0" blurRad="101600" dist="38100" dir="8100000">
+            <a:outerShdw blurRad="101600" dist="38100" dir="8100000" algn="bl" rotWithShape="0">
               <a:srgbClr val="000000">
                 <a:alpha val="18000"/>
               </a:srgbClr>
@@ -3271,7 +3023,7 @@
           <a:bodyPr wrap="square" rtlCol="0" anchor="ctr"/>
           <a:lstStyle/>
           <a:p>
-            <a:pPr algn="ctr" indent="0" marL="0">
+            <a:pPr marL="0" indent="0" algn="ctr">
               <a:buNone/>
             </a:pPr>
             <a:r>
@@ -3310,7 +3062,7 @@
           <a:bodyPr wrap="square" rtlCol="0" anchor="ctr"/>
           <a:lstStyle/>
           <a:p>
-            <a:pPr indent="0" marL="0">
+            <a:pPr marL="0" indent="0">
               <a:buNone/>
             </a:pPr>
             <a:r>
@@ -3349,7 +3101,7 @@
           <a:bodyPr wrap="square" rtlCol="0" anchor="t"/>
           <a:lstStyle/>
           <a:p>
-            <a:pPr indent="0" marL="0">
+            <a:pPr marL="0" indent="0">
               <a:buNone/>
             </a:pPr>
             <a:r>
@@ -3388,7 +3140,7 @@
           </a:solidFill>
           <a:ln/>
           <a:effectLst>
-            <a:outerShdw sx="100000" sy="100000" kx="0" ky="0" algn="bl" rotWithShape="0" blurRad="101600" dist="38100" dir="8100000">
+            <a:outerShdw blurRad="101600" dist="38100" dir="8100000" algn="bl" rotWithShape="0">
               <a:srgbClr val="000000">
                 <a:alpha val="18000"/>
               </a:srgbClr>
@@ -3437,7 +3189,7 @@
           <a:bodyPr wrap="square" rtlCol="0" anchor="ctr"/>
           <a:lstStyle/>
           <a:p>
-            <a:pPr algn="ctr" indent="0" marL="0">
+            <a:pPr marL="0" indent="0" algn="ctr">
               <a:buNone/>
             </a:pPr>
             <a:r>
@@ -3476,7 +3228,7 @@
           <a:bodyPr wrap="square" rtlCol="0" anchor="ctr"/>
           <a:lstStyle/>
           <a:p>
-            <a:pPr indent="0" marL="0">
+            <a:pPr marL="0" indent="0">
               <a:buNone/>
             </a:pPr>
             <a:r>
@@ -3515,7 +3267,7 @@
           <a:bodyPr wrap="square" rtlCol="0" anchor="t"/>
           <a:lstStyle/>
           <a:p>
-            <a:pPr indent="0" marL="0">
+            <a:pPr marL="0" indent="0">
               <a:buNone/>
             </a:pPr>
             <a:r>
@@ -3554,7 +3306,7 @@
           </a:solidFill>
           <a:ln/>
           <a:effectLst>
-            <a:outerShdw sx="100000" sy="100000" kx="0" ky="0" algn="bl" rotWithShape="0" blurRad="101600" dist="38100" dir="8100000">
+            <a:outerShdw blurRad="101600" dist="38100" dir="8100000" algn="bl" rotWithShape="0">
               <a:srgbClr val="000000">
                 <a:alpha val="18000"/>
               </a:srgbClr>
@@ -3603,7 +3355,7 @@
           <a:bodyPr wrap="square" rtlCol="0" anchor="ctr"/>
           <a:lstStyle/>
           <a:p>
-            <a:pPr algn="ctr" indent="0" marL="0">
+            <a:pPr marL="0" indent="0" algn="ctr">
               <a:buNone/>
             </a:pPr>
             <a:r>
@@ -3642,7 +3394,7 @@
           <a:bodyPr wrap="square" rtlCol="0" anchor="ctr"/>
           <a:lstStyle/>
           <a:p>
-            <a:pPr indent="0" marL="0">
+            <a:pPr marL="0" indent="0">
               <a:buNone/>
             </a:pPr>
             <a:r>
@@ -3681,7 +3433,7 @@
           <a:bodyPr wrap="square" rtlCol="0" anchor="t"/>
           <a:lstStyle/>
           <a:p>
-            <a:pPr indent="0" marL="0">
+            <a:pPr marL="0" indent="0">
               <a:buNone/>
             </a:pPr>
             <a:r>
@@ -3720,7 +3472,7 @@
           </a:solidFill>
           <a:ln/>
           <a:effectLst>
-            <a:outerShdw sx="100000" sy="100000" kx="0" ky="0" algn="bl" rotWithShape="0" blurRad="101600" dist="38100" dir="8100000">
+            <a:outerShdw blurRad="101600" dist="38100" dir="8100000" algn="bl" rotWithShape="0">
               <a:srgbClr val="000000">
                 <a:alpha val="18000"/>
               </a:srgbClr>
@@ -3769,7 +3521,7 @@
           <a:bodyPr wrap="square" rtlCol="0" anchor="ctr"/>
           <a:lstStyle/>
           <a:p>
-            <a:pPr algn="ctr" indent="0" marL="0">
+            <a:pPr marL="0" indent="0" algn="ctr">
               <a:buNone/>
             </a:pPr>
             <a:r>
@@ -3808,7 +3560,7 @@
           <a:bodyPr wrap="square" rtlCol="0" anchor="ctr"/>
           <a:lstStyle/>
           <a:p>
-            <a:pPr indent="0" marL="0">
+            <a:pPr marL="0" indent="0">
               <a:buNone/>
             </a:pPr>
             <a:r>
@@ -3847,7 +3599,7 @@
           <a:bodyPr wrap="square" rtlCol="0" anchor="t"/>
           <a:lstStyle/>
           <a:p>
-            <a:pPr indent="0" marL="0">
+            <a:pPr marL="0" indent="0">
               <a:buNone/>
             </a:pPr>
             <a:r>
@@ -3886,7 +3638,7 @@
           </a:solidFill>
           <a:ln/>
           <a:effectLst>
-            <a:outerShdw sx="100000" sy="100000" kx="0" ky="0" algn="bl" rotWithShape="0" blurRad="101600" dist="38100" dir="8100000">
+            <a:outerShdw blurRad="101600" dist="38100" dir="8100000" algn="bl" rotWithShape="0">
               <a:srgbClr val="000000">
                 <a:alpha val="18000"/>
               </a:srgbClr>
@@ -3935,7 +3687,7 @@
           <a:bodyPr wrap="square" rtlCol="0" anchor="ctr"/>
           <a:lstStyle/>
           <a:p>
-            <a:pPr algn="ctr" indent="0" marL="0">
+            <a:pPr marL="0" indent="0" algn="ctr">
               <a:buNone/>
             </a:pPr>
             <a:r>
@@ -3974,7 +3726,7 @@
           <a:bodyPr wrap="square" rtlCol="0" anchor="ctr"/>
           <a:lstStyle/>
           <a:p>
-            <a:pPr indent="0" marL="0">
+            <a:pPr marL="0" indent="0">
               <a:buNone/>
             </a:pPr>
             <a:r>
@@ -4013,7 +3765,7 @@
           <a:bodyPr wrap="square" rtlCol="0" anchor="t"/>
           <a:lstStyle/>
           <a:p>
-            <a:pPr indent="0" marL="0">
+            <a:pPr marL="0" indent="0">
               <a:buNone/>
             </a:pPr>
             <a:r>
@@ -4052,7 +3804,7 @@
           </a:solidFill>
           <a:ln/>
           <a:effectLst>
-            <a:outerShdw sx="100000" sy="100000" kx="0" ky="0" algn="bl" rotWithShape="0" blurRad="101600" dist="38100" dir="8100000">
+            <a:outerShdw blurRad="101600" dist="38100" dir="8100000" algn="bl" rotWithShape="0">
               <a:srgbClr val="000000">
                 <a:alpha val="18000"/>
               </a:srgbClr>
@@ -4101,7 +3853,7 @@
           <a:bodyPr wrap="square" rtlCol="0" anchor="ctr"/>
           <a:lstStyle/>
           <a:p>
-            <a:pPr algn="ctr" indent="0" marL="0">
+            <a:pPr marL="0" indent="0" algn="ctr">
               <a:buNone/>
             </a:pPr>
             <a:r>
@@ -4140,7 +3892,7 @@
           <a:bodyPr wrap="square" rtlCol="0" anchor="ctr"/>
           <a:lstStyle/>
           <a:p>
-            <a:pPr indent="0" marL="0">
+            <a:pPr marL="0" indent="0">
               <a:buNone/>
             </a:pPr>
             <a:r>
@@ -4179,7 +3931,7 @@
           <a:bodyPr wrap="square" rtlCol="0" anchor="t"/>
           <a:lstStyle/>
           <a:p>
-            <a:pPr indent="0" marL="0">
+            <a:pPr marL="0" indent="0">
               <a:buNone/>
             </a:pPr>
             <a:r>
@@ -4213,6 +3965,7 @@
         <a:solidFill>
           <a:srgbClr val="FFFFFF"/>
         </a:solidFill>
+        <a:effectLst/>
       </p:bgPr>
     </p:bg>
     <p:spTree>
@@ -4250,7 +4003,7 @@
           <a:bodyPr wrap="square" rtlCol="0" anchor="ctr"/>
           <a:lstStyle/>
           <a:p>
-            <a:pPr indent="0" marL="0">
+            <a:pPr marL="0" indent="0">
               <a:buNone/>
             </a:pPr>
             <a:r>
@@ -4289,7 +4042,7 @@
           <a:bodyPr wrap="square" rtlCol="0" anchor="ctr"/>
           <a:lstStyle/>
           <a:p>
-            <a:pPr indent="0" marL="0">
+            <a:pPr marL="0" indent="0">
               <a:buNone/>
             </a:pPr>
             <a:r>
@@ -4351,217 +4104,7 @@
       </p:sp>
       <p:pic>
         <p:nvPicPr>
-          <p:cNvPr id="6" name="Image 0" descr="preencoded.png">    </p:cNvPr>
-          <p:cNvPicPr>
-            <a:picLocks noChangeAspect="1"/>
-          </p:cNvPicPr>
-          <p:nvPr/>
-        </p:nvPicPr>
-        <p:blipFill>
-          <a:blip r:embed="rId1"/>
-          <a:stretch>
-            <a:fillRect/>
-          </a:stretch>
-        </p:blipFill>
-        <p:spPr>
-          <a:xfrm>
-            <a:off x="960120" y="1856232"/>
-            <a:ext cx="146304" cy="146304"/>
-          </a:xfrm>
-          <a:prstGeom prst="rect">
-            <a:avLst/>
-          </a:prstGeom>
-        </p:spPr>
-      </p:pic>
-      <p:sp>
-        <p:nvSpPr>
-          <p:cNvPr id="7" name="Text 4"/>
-          <p:cNvSpPr/>
-          <p:nvPr/>
-        </p:nvSpPr>
-        <p:spPr>
-          <a:xfrm>
-            <a:off x="1280160" y="1645920"/>
-            <a:ext cx="4297680" cy="566928"/>
-          </a:xfrm>
-          <a:prstGeom prst="rect">
-            <a:avLst/>
-          </a:prstGeom>
-          <a:noFill/>
-          <a:ln/>
-        </p:spPr>
-        <p:txBody>
-          <a:bodyPr wrap="square" rtlCol="0" anchor="ctr"/>
-          <a:lstStyle/>
-          <a:p>
-            <a:pPr indent="0" marL="0">
-              <a:buNone/>
-            </a:pPr>
-            <a:r>
-              <a:rPr lang="en-US" sz="1500" dirty="0">
-                <a:solidFill>
-                  <a:srgbClr val="1E293B"/>
-                </a:solidFill>
-                <a:latin typeface="Consolas" pitchFamily="34" charset="0"/>
-                <a:ea typeface="Consolas" pitchFamily="34" charset="-122"/>
-                <a:cs typeface="Consolas" pitchFamily="34" charset="-120"/>
-              </a:rPr>
-              <a:t>AGENT_START</a:t>
-            </a:r>
-            <a:endParaRPr lang="en-US" sz="1500" dirty="0"/>
-          </a:p>
-        </p:txBody>
-      </p:sp>
-      <p:sp>
-        <p:nvSpPr>
-          <p:cNvPr id="8" name="Shape 5"/>
-          <p:cNvSpPr/>
-          <p:nvPr/>
-        </p:nvSpPr>
-        <p:spPr>
-          <a:xfrm>
-            <a:off x="749808" y="2304288"/>
-            <a:ext cx="5029200" cy="566928"/>
-          </a:xfrm>
-          <a:prstGeom prst="roundRect">
-            <a:avLst>
-              <a:gd name="adj" fmla="val 9677"/>
-            </a:avLst>
-          </a:prstGeom>
-          <a:solidFill>
-            <a:srgbClr val="F4F7F8"/>
-          </a:solidFill>
-          <a:ln/>
-        </p:spPr>
-      </p:sp>
-      <p:sp>
-        <p:nvSpPr>
-          <p:cNvPr id="9" name="Shape 6"/>
-          <p:cNvSpPr/>
-          <p:nvPr/>
-        </p:nvSpPr>
-        <p:spPr>
-          <a:xfrm>
-            <a:off x="749808" y="2304288"/>
-            <a:ext cx="73152" cy="566928"/>
-          </a:xfrm>
-          <a:prstGeom prst="rect">
-            <a:avLst/>
-          </a:prstGeom>
-          <a:solidFill>
-            <a:srgbClr val="00A896"/>
-          </a:solidFill>
-          <a:ln/>
-        </p:spPr>
-      </p:sp>
-      <p:pic>
-        <p:nvPicPr>
-          <p:cNvPr id="10" name="Image 1" descr="preencoded.png">    </p:cNvPr>
-          <p:cNvPicPr>
-            <a:picLocks noChangeAspect="1"/>
-          </p:cNvPicPr>
-          <p:nvPr/>
-        </p:nvPicPr>
-        <p:blipFill>
-          <a:blip r:embed="rId2"/>
-          <a:stretch>
-            <a:fillRect/>
-          </a:stretch>
-        </p:blipFill>
-        <p:spPr>
-          <a:xfrm>
-            <a:off x="960120" y="2514600"/>
-            <a:ext cx="146304" cy="146304"/>
-          </a:xfrm>
-          <a:prstGeom prst="rect">
-            <a:avLst/>
-          </a:prstGeom>
-        </p:spPr>
-      </p:pic>
-      <p:sp>
-        <p:nvSpPr>
-          <p:cNvPr id="11" name="Text 7"/>
-          <p:cNvSpPr/>
-          <p:nvPr/>
-        </p:nvSpPr>
-        <p:spPr>
-          <a:xfrm>
-            <a:off x="1280160" y="2304288"/>
-            <a:ext cx="4297680" cy="566928"/>
-          </a:xfrm>
-          <a:prstGeom prst="rect">
-            <a:avLst/>
-          </a:prstGeom>
-          <a:noFill/>
-          <a:ln/>
-        </p:spPr>
-        <p:txBody>
-          <a:bodyPr wrap="square" rtlCol="0" anchor="ctr"/>
-          <a:lstStyle/>
-          <a:p>
-            <a:pPr indent="0" marL="0">
-              <a:buNone/>
-            </a:pPr>
-            <a:r>
-              <a:rPr lang="en-US" sz="1500" dirty="0">
-                <a:solidFill>
-                  <a:srgbClr val="1E293B"/>
-                </a:solidFill>
-                <a:latin typeface="Consolas" pitchFamily="34" charset="0"/>
-                <a:ea typeface="Consolas" pitchFamily="34" charset="-122"/>
-                <a:cs typeface="Consolas" pitchFamily="34" charset="-120"/>
-              </a:rPr>
-              <a:t>AGENT_STEP</a:t>
-            </a:r>
-            <a:endParaRPr lang="en-US" sz="1500" dirty="0"/>
-          </a:p>
-        </p:txBody>
-      </p:sp>
-      <p:sp>
-        <p:nvSpPr>
-          <p:cNvPr id="12" name="Shape 8"/>
-          <p:cNvSpPr/>
-          <p:nvPr/>
-        </p:nvSpPr>
-        <p:spPr>
-          <a:xfrm>
-            <a:off x="749808" y="2962656"/>
-            <a:ext cx="5029200" cy="566928"/>
-          </a:xfrm>
-          <a:prstGeom prst="roundRect">
-            <a:avLst>
-              <a:gd name="adj" fmla="val 9677"/>
-            </a:avLst>
-          </a:prstGeom>
-          <a:solidFill>
-            <a:srgbClr val="F4F7F8"/>
-          </a:solidFill>
-          <a:ln/>
-        </p:spPr>
-      </p:sp>
-      <p:sp>
-        <p:nvSpPr>
-          <p:cNvPr id="13" name="Shape 9"/>
-          <p:cNvSpPr/>
-          <p:nvPr/>
-        </p:nvSpPr>
-        <p:spPr>
-          <a:xfrm>
-            <a:off x="749808" y="2962656"/>
-            <a:ext cx="73152" cy="566928"/>
-          </a:xfrm>
-          <a:prstGeom prst="rect">
-            <a:avLst/>
-          </a:prstGeom>
-          <a:solidFill>
-            <a:srgbClr val="00A896"/>
-          </a:solidFill>
-          <a:ln/>
-        </p:spPr>
-      </p:sp>
-      <p:pic>
-        <p:nvPicPr>
-          <p:cNvPr id="14" name="Image 2" descr="preencoded.png">    </p:cNvPr>
+          <p:cNvPr id="6" name="Image 0" descr="preencoded.png"/>
           <p:cNvPicPr>
             <a:picLocks noChangeAspect="1"/>
           </p:cNvPicPr>
@@ -4575,7 +4118,7 @@
         </p:blipFill>
         <p:spPr>
           <a:xfrm>
-            <a:off x="960120" y="3172968"/>
+            <a:off x="960120" y="1856232"/>
             <a:ext cx="146304" cy="146304"/>
           </a:xfrm>
           <a:prstGeom prst="rect">
@@ -4585,13 +4128,13 @@
       </p:pic>
       <p:sp>
         <p:nvSpPr>
-          <p:cNvPr id="15" name="Text 10"/>
-          <p:cNvSpPr/>
-          <p:nvPr/>
-        </p:nvSpPr>
-        <p:spPr>
-          <a:xfrm>
-            <a:off x="1280160" y="2962656"/>
+          <p:cNvPr id="7" name="Text 4"/>
+          <p:cNvSpPr/>
+          <p:nvPr/>
+        </p:nvSpPr>
+        <p:spPr>
+          <a:xfrm>
+            <a:off x="1280160" y="1645920"/>
             <a:ext cx="4297680" cy="566928"/>
           </a:xfrm>
           <a:prstGeom prst="rect">
@@ -4604,7 +4147,7 @@
           <a:bodyPr wrap="square" rtlCol="0" anchor="ctr"/>
           <a:lstStyle/>
           <a:p>
-            <a:pPr indent="0" marL="0">
+            <a:pPr marL="0" indent="0">
               <a:buNone/>
             </a:pPr>
             <a:r>
@@ -4616,7 +4159,7 @@
                 <a:ea typeface="Consolas" pitchFamily="34" charset="-122"/>
                 <a:cs typeface="Consolas" pitchFamily="34" charset="-120"/>
               </a:rPr>
-              <a:t>TOOL_CALL</a:t>
+              <a:t>AGENT_START</a:t>
             </a:r>
             <a:endParaRPr lang="en-US" sz="1500" dirty="0"/>
           </a:p>
@@ -4624,13 +4167,13 @@
       </p:sp>
       <p:sp>
         <p:nvSpPr>
-          <p:cNvPr id="16" name="Shape 11"/>
-          <p:cNvSpPr/>
-          <p:nvPr/>
-        </p:nvSpPr>
-        <p:spPr>
-          <a:xfrm>
-            <a:off x="749808" y="3621024"/>
+          <p:cNvPr id="8" name="Shape 5"/>
+          <p:cNvSpPr/>
+          <p:nvPr/>
+        </p:nvSpPr>
+        <p:spPr>
+          <a:xfrm>
+            <a:off x="749808" y="2304288"/>
             <a:ext cx="5029200" cy="566928"/>
           </a:xfrm>
           <a:prstGeom prst="roundRect">
@@ -4646,6 +4189,216 @@
       </p:sp>
       <p:sp>
         <p:nvSpPr>
+          <p:cNvPr id="9" name="Shape 6"/>
+          <p:cNvSpPr/>
+          <p:nvPr/>
+        </p:nvSpPr>
+        <p:spPr>
+          <a:xfrm>
+            <a:off x="749808" y="2304288"/>
+            <a:ext cx="73152" cy="566928"/>
+          </a:xfrm>
+          <a:prstGeom prst="rect">
+            <a:avLst/>
+          </a:prstGeom>
+          <a:solidFill>
+            <a:srgbClr val="00A896"/>
+          </a:solidFill>
+          <a:ln/>
+        </p:spPr>
+      </p:sp>
+      <p:pic>
+        <p:nvPicPr>
+          <p:cNvPr id="10" name="Image 1" descr="preencoded.png"/>
+          <p:cNvPicPr>
+            <a:picLocks noChangeAspect="1"/>
+          </p:cNvPicPr>
+          <p:nvPr/>
+        </p:nvPicPr>
+        <p:blipFill>
+          <a:blip r:embed="rId3"/>
+          <a:stretch>
+            <a:fillRect/>
+          </a:stretch>
+        </p:blipFill>
+        <p:spPr>
+          <a:xfrm>
+            <a:off x="960120" y="2514600"/>
+            <a:ext cx="146304" cy="146304"/>
+          </a:xfrm>
+          <a:prstGeom prst="rect">
+            <a:avLst/>
+          </a:prstGeom>
+        </p:spPr>
+      </p:pic>
+      <p:sp>
+        <p:nvSpPr>
+          <p:cNvPr id="11" name="Text 7"/>
+          <p:cNvSpPr/>
+          <p:nvPr/>
+        </p:nvSpPr>
+        <p:spPr>
+          <a:xfrm>
+            <a:off x="1280160" y="2304288"/>
+            <a:ext cx="4297680" cy="566928"/>
+          </a:xfrm>
+          <a:prstGeom prst="rect">
+            <a:avLst/>
+          </a:prstGeom>
+          <a:noFill/>
+          <a:ln/>
+        </p:spPr>
+        <p:txBody>
+          <a:bodyPr wrap="square" rtlCol="0" anchor="ctr"/>
+          <a:lstStyle/>
+          <a:p>
+            <a:pPr marL="0" indent="0">
+              <a:buNone/>
+            </a:pPr>
+            <a:r>
+              <a:rPr lang="en-US" sz="1500" dirty="0">
+                <a:solidFill>
+                  <a:srgbClr val="1E293B"/>
+                </a:solidFill>
+                <a:latin typeface="Consolas" pitchFamily="34" charset="0"/>
+                <a:ea typeface="Consolas" pitchFamily="34" charset="-122"/>
+                <a:cs typeface="Consolas" pitchFamily="34" charset="-120"/>
+              </a:rPr>
+              <a:t>AGENT_STEP</a:t>
+            </a:r>
+            <a:endParaRPr lang="en-US" sz="1500" dirty="0"/>
+          </a:p>
+        </p:txBody>
+      </p:sp>
+      <p:sp>
+        <p:nvSpPr>
+          <p:cNvPr id="12" name="Shape 8"/>
+          <p:cNvSpPr/>
+          <p:nvPr/>
+        </p:nvSpPr>
+        <p:spPr>
+          <a:xfrm>
+            <a:off x="749808" y="2962656"/>
+            <a:ext cx="5029200" cy="566928"/>
+          </a:xfrm>
+          <a:prstGeom prst="roundRect">
+            <a:avLst>
+              <a:gd name="adj" fmla="val 9677"/>
+            </a:avLst>
+          </a:prstGeom>
+          <a:solidFill>
+            <a:srgbClr val="F4F7F8"/>
+          </a:solidFill>
+          <a:ln/>
+        </p:spPr>
+      </p:sp>
+      <p:sp>
+        <p:nvSpPr>
+          <p:cNvPr id="13" name="Shape 9"/>
+          <p:cNvSpPr/>
+          <p:nvPr/>
+        </p:nvSpPr>
+        <p:spPr>
+          <a:xfrm>
+            <a:off x="749808" y="2962656"/>
+            <a:ext cx="73152" cy="566928"/>
+          </a:xfrm>
+          <a:prstGeom prst="rect">
+            <a:avLst/>
+          </a:prstGeom>
+          <a:solidFill>
+            <a:srgbClr val="00A896"/>
+          </a:solidFill>
+          <a:ln/>
+        </p:spPr>
+      </p:sp>
+      <p:pic>
+        <p:nvPicPr>
+          <p:cNvPr id="14" name="Image 2" descr="preencoded.png"/>
+          <p:cNvPicPr>
+            <a:picLocks noChangeAspect="1"/>
+          </p:cNvPicPr>
+          <p:nvPr/>
+        </p:nvPicPr>
+        <p:blipFill>
+          <a:blip r:embed="rId3"/>
+          <a:stretch>
+            <a:fillRect/>
+          </a:stretch>
+        </p:blipFill>
+        <p:spPr>
+          <a:xfrm>
+            <a:off x="960120" y="3172968"/>
+            <a:ext cx="146304" cy="146304"/>
+          </a:xfrm>
+          <a:prstGeom prst="rect">
+            <a:avLst/>
+          </a:prstGeom>
+        </p:spPr>
+      </p:pic>
+      <p:sp>
+        <p:nvSpPr>
+          <p:cNvPr id="15" name="Text 10"/>
+          <p:cNvSpPr/>
+          <p:nvPr/>
+        </p:nvSpPr>
+        <p:spPr>
+          <a:xfrm>
+            <a:off x="1280160" y="2962656"/>
+            <a:ext cx="4297680" cy="566928"/>
+          </a:xfrm>
+          <a:prstGeom prst="rect">
+            <a:avLst/>
+          </a:prstGeom>
+          <a:noFill/>
+          <a:ln/>
+        </p:spPr>
+        <p:txBody>
+          <a:bodyPr wrap="square" rtlCol="0" anchor="ctr"/>
+          <a:lstStyle/>
+          <a:p>
+            <a:pPr marL="0" indent="0">
+              <a:buNone/>
+            </a:pPr>
+            <a:r>
+              <a:rPr lang="en-US" sz="1500" dirty="0">
+                <a:solidFill>
+                  <a:srgbClr val="1E293B"/>
+                </a:solidFill>
+                <a:latin typeface="Consolas" pitchFamily="34" charset="0"/>
+                <a:ea typeface="Consolas" pitchFamily="34" charset="-122"/>
+                <a:cs typeface="Consolas" pitchFamily="34" charset="-120"/>
+              </a:rPr>
+              <a:t>TOOL_CALL</a:t>
+            </a:r>
+            <a:endParaRPr lang="en-US" sz="1500" dirty="0"/>
+          </a:p>
+        </p:txBody>
+      </p:sp>
+      <p:sp>
+        <p:nvSpPr>
+          <p:cNvPr id="16" name="Shape 11"/>
+          <p:cNvSpPr/>
+          <p:nvPr/>
+        </p:nvSpPr>
+        <p:spPr>
+          <a:xfrm>
+            <a:off x="749808" y="3621024"/>
+            <a:ext cx="5029200" cy="566928"/>
+          </a:xfrm>
+          <a:prstGeom prst="roundRect">
+            <a:avLst>
+              <a:gd name="adj" fmla="val 9677"/>
+            </a:avLst>
+          </a:prstGeom>
+          <a:solidFill>
+            <a:srgbClr val="F4F7F8"/>
+          </a:solidFill>
+          <a:ln/>
+        </p:spPr>
+      </p:sp>
+      <p:sp>
+        <p:nvSpPr>
           <p:cNvPr id="17" name="Shape 12"/>
           <p:cNvSpPr/>
           <p:nvPr/>
@@ -4666,7 +4419,168 @@
       </p:sp>
       <p:pic>
         <p:nvPicPr>
-          <p:cNvPr id="18" name="Image 3" descr="preencoded.png">    </p:cNvPr>
+          <p:cNvPr id="18" name="Image 3" descr="preencoded.png"/>
+          <p:cNvPicPr>
+            <a:picLocks noChangeAspect="1"/>
+          </p:cNvPicPr>
+          <p:nvPr/>
+        </p:nvPicPr>
+        <p:blipFill>
+          <a:blip r:embed="rId3"/>
+          <a:stretch>
+            <a:fillRect/>
+          </a:stretch>
+        </p:blipFill>
+        <p:spPr>
+          <a:xfrm>
+            <a:off x="960120" y="3831336"/>
+            <a:ext cx="146304" cy="146304"/>
+          </a:xfrm>
+          <a:prstGeom prst="rect">
+            <a:avLst/>
+          </a:prstGeom>
+        </p:spPr>
+      </p:pic>
+      <p:sp>
+        <p:nvSpPr>
+          <p:cNvPr id="19" name="Text 13"/>
+          <p:cNvSpPr/>
+          <p:nvPr/>
+        </p:nvSpPr>
+        <p:spPr>
+          <a:xfrm>
+            <a:off x="1280160" y="3621024"/>
+            <a:ext cx="4297680" cy="566928"/>
+          </a:xfrm>
+          <a:prstGeom prst="rect">
+            <a:avLst/>
+          </a:prstGeom>
+          <a:noFill/>
+          <a:ln/>
+        </p:spPr>
+        <p:txBody>
+          <a:bodyPr wrap="square" rtlCol="0" anchor="ctr"/>
+          <a:lstStyle/>
+          <a:p>
+            <a:pPr marL="0" indent="0">
+              <a:buNone/>
+            </a:pPr>
+            <a:r>
+              <a:rPr lang="en-US" sz="1500" dirty="0">
+                <a:solidFill>
+                  <a:srgbClr val="1E293B"/>
+                </a:solidFill>
+                <a:latin typeface="Consolas" pitchFamily="34" charset="0"/>
+                <a:ea typeface="Consolas" pitchFamily="34" charset="-122"/>
+                <a:cs typeface="Consolas" pitchFamily="34" charset="-120"/>
+              </a:rPr>
+              <a:t>AGENT_END</a:t>
+            </a:r>
+            <a:endParaRPr lang="en-US" sz="1500" dirty="0"/>
+          </a:p>
+        </p:txBody>
+      </p:sp>
+      <p:sp>
+        <p:nvSpPr>
+          <p:cNvPr id="20" name="Text 14"/>
+          <p:cNvSpPr/>
+          <p:nvPr/>
+        </p:nvSpPr>
+        <p:spPr>
+          <a:xfrm>
+            <a:off x="749808" y="4325112"/>
+            <a:ext cx="5029200" cy="548640"/>
+          </a:xfrm>
+          <a:prstGeom prst="rect">
+            <a:avLst/>
+          </a:prstGeom>
+          <a:noFill/>
+          <a:ln/>
+        </p:spPr>
+        <p:txBody>
+          <a:bodyPr wrap="square" rtlCol="0" anchor="ctr"/>
+          <a:lstStyle/>
+          <a:p>
+            <a:pPr marL="0" indent="0">
+              <a:buNone/>
+            </a:pPr>
+            <a:r>
+              <a:rPr lang="en-US" sz="1250" i="1" dirty="0">
+                <a:solidFill>
+                  <a:srgbClr val="64748B"/>
+                </a:solidFill>
+                <a:latin typeface="Calibri" pitchFamily="34" charset="0"/>
+                <a:ea typeface="Calibri" pitchFamily="34" charset="-122"/>
+                <a:cs typeface="Calibri" pitchFamily="34" charset="-120"/>
+              </a:rPr>
+              <a:t>→ Nguồn sự thật khi debug: parse lỗi, chọn sai tool, vượt max_steps</a:t>
+            </a:r>
+            <a:endParaRPr lang="en-US" sz="1250" dirty="0"/>
+          </a:p>
+        </p:txBody>
+      </p:sp>
+      <p:sp>
+        <p:nvSpPr>
+          <p:cNvPr id="21" name="Shape 15"/>
+          <p:cNvSpPr/>
+          <p:nvPr/>
+        </p:nvSpPr>
+        <p:spPr>
+          <a:xfrm>
+            <a:off x="6309360" y="1143000"/>
+            <a:ext cx="5120640" cy="4754880"/>
+          </a:xfrm>
+          <a:prstGeom prst="rect">
+            <a:avLst/>
+          </a:prstGeom>
+          <a:solidFill>
+            <a:srgbClr val="0B2545"/>
+          </a:solidFill>
+          <a:ln/>
+        </p:spPr>
+      </p:sp>
+      <p:sp>
+        <p:nvSpPr>
+          <p:cNvPr id="22" name="Text 16"/>
+          <p:cNvSpPr/>
+          <p:nvPr/>
+        </p:nvSpPr>
+        <p:spPr>
+          <a:xfrm>
+            <a:off x="6583680" y="1371600"/>
+            <a:ext cx="4572000" cy="457200"/>
+          </a:xfrm>
+          <a:prstGeom prst="rect">
+            <a:avLst/>
+          </a:prstGeom>
+          <a:noFill/>
+          <a:ln/>
+        </p:spPr>
+        <p:txBody>
+          <a:bodyPr wrap="square" rtlCol="0" anchor="ctr"/>
+          <a:lstStyle/>
+          <a:p>
+            <a:pPr marL="0" indent="0">
+              <a:buNone/>
+            </a:pPr>
+            <a:r>
+              <a:rPr lang="en-US" sz="2200" b="1" dirty="0">
+                <a:solidFill>
+                  <a:srgbClr val="02C39A"/>
+                </a:solidFill>
+                <a:latin typeface="Georgia" pitchFamily="34" charset="0"/>
+                <a:ea typeface="Georgia" pitchFamily="34" charset="-122"/>
+                <a:cs typeface="Georgia" pitchFamily="34" charset="-120"/>
+              </a:rPr>
+              <a:t>Takeaways</a:t>
+            </a:r>
+            <a:endParaRPr lang="en-US" sz="2200" dirty="0"/>
+          </a:p>
+        </p:txBody>
+      </p:sp>
+      <p:pic>
+        <p:nvPicPr>
+          <p:cNvPr id="23" name="Image 4" descr="preencoded.png"/>
           <p:cNvPicPr>
             <a:picLocks noChangeAspect="1"/>
           </p:cNvPicPr>
@@ -4680,8 +4594,8 @@
         </p:blipFill>
         <p:spPr>
           <a:xfrm>
-            <a:off x="960120" y="3831336"/>
-            <a:ext cx="146304" cy="146304"/>
+            <a:off x="6583680" y="1993392"/>
+            <a:ext cx="292608" cy="292608"/>
           </a:xfrm>
           <a:prstGeom prst="rect">
             <a:avLst/>
@@ -4690,158 +4604,60 @@
       </p:pic>
       <p:sp>
         <p:nvSpPr>
-          <p:cNvPr id="19" name="Text 13"/>
-          <p:cNvSpPr/>
-          <p:nvPr/>
-        </p:nvSpPr>
-        <p:spPr>
-          <a:xfrm>
-            <a:off x="1280160" y="3621024"/>
-            <a:ext cx="4297680" cy="566928"/>
-          </a:xfrm>
-          <a:prstGeom prst="rect">
-            <a:avLst/>
-          </a:prstGeom>
-          <a:noFill/>
-          <a:ln/>
-        </p:spPr>
-        <p:txBody>
-          <a:bodyPr wrap="square" rtlCol="0" anchor="ctr"/>
-          <a:lstStyle/>
-          <a:p>
-            <a:pPr indent="0" marL="0">
+          <p:cNvPr id="24" name="Text 17"/>
+          <p:cNvSpPr/>
+          <p:nvPr/>
+        </p:nvSpPr>
+        <p:spPr>
+          <a:xfrm>
+            <a:off x="6995160" y="1920240"/>
+            <a:ext cx="4206240" cy="868680"/>
+          </a:xfrm>
+          <a:prstGeom prst="rect">
+            <a:avLst/>
+          </a:prstGeom>
+          <a:noFill/>
+          <a:ln/>
+        </p:spPr>
+        <p:txBody>
+          <a:bodyPr wrap="square" rtlCol="0" anchor="t"/>
+          <a:lstStyle/>
+          <a:p>
+            <a:pPr marL="0" indent="0">
               <a:buNone/>
             </a:pPr>
             <a:r>
-              <a:rPr lang="en-US" sz="1500" dirty="0">
-                <a:solidFill>
-                  <a:srgbClr val="1E293B"/>
-                </a:solidFill>
-                <a:latin typeface="Consolas" pitchFamily="34" charset="0"/>
-                <a:ea typeface="Consolas" pitchFamily="34" charset="-122"/>
-                <a:cs typeface="Consolas" pitchFamily="34" charset="-120"/>
-              </a:rPr>
-              <a:t>AGENT_END</a:t>
-            </a:r>
-            <a:endParaRPr lang="en-US" sz="1500" dirty="0"/>
-          </a:p>
-        </p:txBody>
-      </p:sp>
-      <p:sp>
-        <p:nvSpPr>
-          <p:cNvPr id="20" name="Text 14"/>
-          <p:cNvSpPr/>
-          <p:nvPr/>
-        </p:nvSpPr>
-        <p:spPr>
-          <a:xfrm>
-            <a:off x="749808" y="4325112"/>
-            <a:ext cx="5029200" cy="548640"/>
-          </a:xfrm>
-          <a:prstGeom prst="rect">
-            <a:avLst/>
-          </a:prstGeom>
-          <a:noFill/>
-          <a:ln/>
-        </p:spPr>
-        <p:txBody>
-          <a:bodyPr wrap="square" rtlCol="0" anchor="ctr"/>
-          <a:lstStyle/>
-          <a:p>
-            <a:pPr indent="0" marL="0">
-              <a:buNone/>
-            </a:pPr>
-            <a:r>
-              <a:rPr lang="en-US" sz="1250" i="1" dirty="0">
-                <a:solidFill>
-                  <a:srgbClr val="64748B"/>
+              <a:rPr lang="en-US" sz="1450" dirty="0">
+                <a:solidFill>
+                  <a:srgbClr val="E8F0FE"/>
                 </a:solidFill>
                 <a:latin typeface="Calibri" pitchFamily="34" charset="0"/>
                 <a:ea typeface="Calibri" pitchFamily="34" charset="-122"/>
                 <a:cs typeface="Calibri" pitchFamily="34" charset="-120"/>
               </a:rPr>
-              <a:t>→ Nguồn sự thật khi debug: parse lỗi, chọn sai tool, vượt max_steps</a:t>
-            </a:r>
-            <a:endParaRPr lang="en-US" sz="1250" dirty="0"/>
-          </a:p>
-        </p:txBody>
-      </p:sp>
-      <p:sp>
-        <p:nvSpPr>
-          <p:cNvPr id="21" name="Shape 15"/>
-          <p:cNvSpPr/>
-          <p:nvPr/>
-        </p:nvSpPr>
-        <p:spPr>
-          <a:xfrm>
-            <a:off x="6309360" y="1143000"/>
-            <a:ext cx="5120640" cy="4754880"/>
-          </a:xfrm>
-          <a:prstGeom prst="rect">
-            <a:avLst/>
-          </a:prstGeom>
-          <a:solidFill>
-            <a:srgbClr val="0B2545"/>
-          </a:solidFill>
-          <a:ln/>
-        </p:spPr>
-      </p:sp>
-      <p:sp>
-        <p:nvSpPr>
-          <p:cNvPr id="22" name="Text 16"/>
-          <p:cNvSpPr/>
-          <p:nvPr/>
-        </p:nvSpPr>
-        <p:spPr>
-          <a:xfrm>
-            <a:off x="6583680" y="1371600"/>
-            <a:ext cx="4572000" cy="457200"/>
-          </a:xfrm>
-          <a:prstGeom prst="rect">
-            <a:avLst/>
-          </a:prstGeom>
-          <a:noFill/>
-          <a:ln/>
-        </p:spPr>
-        <p:txBody>
-          <a:bodyPr wrap="square" rtlCol="0" anchor="ctr"/>
-          <a:lstStyle/>
-          <a:p>
-            <a:pPr indent="0" marL="0">
-              <a:buNone/>
-            </a:pPr>
-            <a:r>
-              <a:rPr lang="en-US" sz="2200" b="1" dirty="0">
-                <a:solidFill>
-                  <a:srgbClr val="02C39A"/>
-                </a:solidFill>
-                <a:latin typeface="Georgia" pitchFamily="34" charset="0"/>
-                <a:ea typeface="Georgia" pitchFamily="34" charset="-122"/>
-                <a:cs typeface="Georgia" pitchFamily="34" charset="-120"/>
-              </a:rPr>
-              <a:t>Takeaways</a:t>
-            </a:r>
-            <a:endParaRPr lang="en-US" sz="2200" dirty="0"/>
+              <a:t>Chatbot hợp Q&amp;A đơn giản; agent hợp chuỗi tra cứu có cấu trúc.</a:t>
+            </a:r>
+            <a:endParaRPr lang="en-US" sz="1450" dirty="0"/>
           </a:p>
         </p:txBody>
       </p:sp>
       <p:pic>
         <p:nvPicPr>
-          <p:cNvPr id="23" name="Image 4" descr="preencoded.png">    </p:cNvPr>
+          <p:cNvPr id="25" name="Image 5" descr="preencoded.png"/>
           <p:cNvPicPr>
             <a:picLocks noChangeAspect="1"/>
           </p:cNvPicPr>
           <p:nvPr/>
         </p:nvPicPr>
         <p:blipFill>
-          <a:blip r:embed="rId5"/>
+          <a:blip r:embed="rId4"/>
           <a:stretch>
             <a:fillRect/>
           </a:stretch>
         </p:blipFill>
         <p:spPr>
           <a:xfrm>
-            <a:off x="6583680" y="1993392"/>
+            <a:off x="6583680" y="2953512"/>
             <a:ext cx="292608" cy="292608"/>
           </a:xfrm>
           <a:prstGeom prst="rect">
@@ -4851,13 +4667,13 @@
       </p:pic>
       <p:sp>
         <p:nvSpPr>
-          <p:cNvPr id="24" name="Text 17"/>
-          <p:cNvSpPr/>
-          <p:nvPr/>
-        </p:nvSpPr>
-        <p:spPr>
-          <a:xfrm>
-            <a:off x="6995160" y="1920240"/>
+          <p:cNvPr id="26" name="Text 18"/>
+          <p:cNvSpPr/>
+          <p:nvPr/>
+        </p:nvSpPr>
+        <p:spPr>
+          <a:xfrm>
+            <a:off x="6995160" y="2880360"/>
             <a:ext cx="4206240" cy="868680"/>
           </a:xfrm>
           <a:prstGeom prst="rect">
@@ -4870,7 +4686,7 @@
           <a:bodyPr wrap="square" rtlCol="0" anchor="t"/>
           <a:lstStyle/>
           <a:p>
-            <a:pPr indent="0" marL="0">
+            <a:pPr marL="0" indent="0">
               <a:buNone/>
             </a:pPr>
             <a:r>
@@ -4882,7 +4698,7 @@
                 <a:ea typeface="Calibri" pitchFamily="34" charset="-122"/>
                 <a:cs typeface="Calibri" pitchFamily="34" charset="-120"/>
               </a:rPr>
-              <a:t>Chatbot hợp Q&amp;A đơn giản; agent hợp chuỗi tra cứu có cấu trúc.</a:t>
+              <a:t>Tool description quyết định LLM chọn tool đúng hay không.</a:t>
             </a:r>
             <a:endParaRPr lang="en-US" sz="1450" dirty="0"/>
           </a:p>
@@ -4890,21 +4706,21 @@
       </p:sp>
       <p:pic>
         <p:nvPicPr>
-          <p:cNvPr id="25" name="Image 5" descr="preencoded.png">    </p:cNvPr>
+          <p:cNvPr id="27" name="Image 6" descr="preencoded.png"/>
           <p:cNvPicPr>
             <a:picLocks noChangeAspect="1"/>
           </p:cNvPicPr>
           <p:nvPr/>
         </p:nvPicPr>
         <p:blipFill>
-          <a:blip r:embed="rId6"/>
+          <a:blip r:embed="rId4"/>
           <a:stretch>
             <a:fillRect/>
           </a:stretch>
         </p:blipFill>
         <p:spPr>
           <a:xfrm>
-            <a:off x="6583680" y="2953512"/>
+            <a:off x="6583680" y="3913632"/>
             <a:ext cx="292608" cy="292608"/>
           </a:xfrm>
           <a:prstGeom prst="rect">
@@ -4914,13 +4730,13 @@
       </p:pic>
       <p:sp>
         <p:nvSpPr>
-          <p:cNvPr id="26" name="Text 18"/>
-          <p:cNvSpPr/>
-          <p:nvPr/>
-        </p:nvSpPr>
-        <p:spPr>
-          <a:xfrm>
-            <a:off x="6995160" y="2880360"/>
+          <p:cNvPr id="28" name="Text 19"/>
+          <p:cNvSpPr/>
+          <p:nvPr/>
+        </p:nvSpPr>
+        <p:spPr>
+          <a:xfrm>
+            <a:off x="6995160" y="3840480"/>
             <a:ext cx="4206240" cy="868680"/>
           </a:xfrm>
           <a:prstGeom prst="rect">
@@ -4933,7 +4749,7 @@
           <a:bodyPr wrap="square" rtlCol="0" anchor="t"/>
           <a:lstStyle/>
           <a:p>
-            <a:pPr indent="0" marL="0">
+            <a:pPr marL="0" indent="0">
               <a:buNone/>
             </a:pPr>
             <a:r>
@@ -4945,7 +4761,7 @@
                 <a:ea typeface="Calibri" pitchFamily="34" charset="-122"/>
                 <a:cs typeface="Calibri" pitchFamily="34" charset="-120"/>
               </a:rPr>
-              <a:t>Tool description quyết định LLM chọn tool đúng hay không.</a:t>
+              <a:t>Log JSON &gt; đoán prompt — ưu tiên đọc trace.</a:t>
             </a:r>
             <a:endParaRPr lang="en-US" sz="1450" dirty="0"/>
           </a:p>
@@ -4953,83 +4769,20 @@
       </p:sp>
       <p:pic>
         <p:nvPicPr>
-          <p:cNvPr id="27" name="Image 6" descr="preencoded.png">    </p:cNvPr>
+          <p:cNvPr id="29" name="Image 7" descr="preencoded.png"/>
           <p:cNvPicPr>
             <a:picLocks noChangeAspect="1"/>
           </p:cNvPicPr>
           <p:nvPr/>
         </p:nvPicPr>
         <p:blipFill>
-          <a:blip r:embed="rId7"/>
+          <a:blip r:embed="rId4"/>
           <a:stretch>
             <a:fillRect/>
           </a:stretch>
         </p:blipFill>
         <p:spPr>
           <a:xfrm>
-            <a:off x="6583680" y="3913632"/>
-            <a:ext cx="292608" cy="292608"/>
-          </a:xfrm>
-          <a:prstGeom prst="rect">
-            <a:avLst/>
-          </a:prstGeom>
-        </p:spPr>
-      </p:pic>
-      <p:sp>
-        <p:nvSpPr>
-          <p:cNvPr id="28" name="Text 19"/>
-          <p:cNvSpPr/>
-          <p:nvPr/>
-        </p:nvSpPr>
-        <p:spPr>
-          <a:xfrm>
-            <a:off x="6995160" y="3840480"/>
-            <a:ext cx="4206240" cy="868680"/>
-          </a:xfrm>
-          <a:prstGeom prst="rect">
-            <a:avLst/>
-          </a:prstGeom>
-          <a:noFill/>
-          <a:ln/>
-        </p:spPr>
-        <p:txBody>
-          <a:bodyPr wrap="square" rtlCol="0" anchor="t"/>
-          <a:lstStyle/>
-          <a:p>
-            <a:pPr indent="0" marL="0">
-              <a:buNone/>
-            </a:pPr>
-            <a:r>
-              <a:rPr lang="en-US" sz="1450" dirty="0">
-                <a:solidFill>
-                  <a:srgbClr val="E8F0FE"/>
-                </a:solidFill>
-                <a:latin typeface="Calibri" pitchFamily="34" charset="0"/>
-                <a:ea typeface="Calibri" pitchFamily="34" charset="-122"/>
-                <a:cs typeface="Calibri" pitchFamily="34" charset="-120"/>
-              </a:rPr>
-              <a:t>Log JSON &gt; đoán prompt — ưu tiên đọc trace.</a:t>
-            </a:r>
-            <a:endParaRPr lang="en-US" sz="1450" dirty="0"/>
-          </a:p>
-        </p:txBody>
-      </p:sp>
-      <p:pic>
-        <p:nvPicPr>
-          <p:cNvPr id="29" name="Image 7" descr="preencoded.png">    </p:cNvPr>
-          <p:cNvPicPr>
-            <a:picLocks noChangeAspect="1"/>
-          </p:cNvPicPr>
-          <p:nvPr/>
-        </p:nvPicPr>
-        <p:blipFill>
-          <a:blip r:embed="rId8"/>
-          <a:stretch>
-            <a:fillRect/>
-          </a:stretch>
-        </p:blipFill>
-        <p:spPr>
-          <a:xfrm>
             <a:off x="6583680" y="4873752"/>
             <a:ext cx="292608" cy="292608"/>
           </a:xfrm>
@@ -5059,7 +4812,7 @@
           <a:bodyPr wrap="square" rtlCol="0" anchor="t"/>
           <a:lstStyle/>
           <a:p>
-            <a:pPr indent="0" marL="0">
+            <a:pPr marL="0" indent="0">
               <a:buNone/>
             </a:pPr>
             <a:r>
@@ -5378,4 +5131,299 @@
     </a:ext>
   </a:extLst>
 </a:theme>
+</file>
+
+<file path=ppt/theme/theme2.xml><?xml version="1.0" encoding="utf-8"?>
+<a:theme xmlns:a="http://schemas.openxmlformats.org/drawingml/2006/main" name="Office Theme">
+  <a:themeElements>
+    <a:clrScheme name="Office">
+      <a:dk1>
+        <a:sysClr val="windowText" lastClr="000000"/>
+      </a:dk1>
+      <a:lt1>
+        <a:sysClr val="window" lastClr="FFFFFF"/>
+      </a:lt1>
+      <a:dk2>
+        <a:srgbClr val="44546A"/>
+      </a:dk2>
+      <a:lt2>
+        <a:srgbClr val="E7E6E6"/>
+      </a:lt2>
+      <a:accent1>
+        <a:srgbClr val="4472C4"/>
+      </a:accent1>
+      <a:accent2>
+        <a:srgbClr val="ED7D31"/>
+      </a:accent2>
+      <a:accent3>
+        <a:srgbClr val="A5A5A5"/>
+      </a:accent3>
+      <a:accent4>
+        <a:srgbClr val="FFC000"/>
+      </a:accent4>
+      <a:accent5>
+        <a:srgbClr val="5B9BD5"/>
+      </a:accent5>
+      <a:accent6>
+        <a:srgbClr val="70AD47"/>
+      </a:accent6>
+      <a:hlink>
+        <a:srgbClr val="0563C1"/>
+      </a:hlink>
+      <a:folHlink>
+        <a:srgbClr val="954F72"/>
+      </a:folHlink>
+    </a:clrScheme>
+    <a:fontScheme name="Office">
+      <a:majorFont>
+        <a:latin typeface="Calibri Light" panose="020F0302020204030204"/>
+        <a:ea typeface=""/>
+        <a:cs typeface=""/>
+        <a:font script="Jpan" typeface="游ゴシック Light"/>
+        <a:font script="Hang" typeface="맑은 고딕"/>
+        <a:font script="Hans" typeface="等线 Light"/>
+        <a:font script="Hant" typeface="新細明體"/>
+        <a:font script="Arab" typeface="Times New Roman"/>
+        <a:font script="Hebr" typeface="Times New Roman"/>
+        <a:font script="Thai" typeface="Angsana New"/>
+        <a:font script="Ethi" typeface="Nyala"/>
+        <a:font script="Beng" typeface="Vrinda"/>
+        <a:font script="Gujr" typeface="Shruti"/>
+        <a:font script="Khmr" typeface="MoolBoran"/>
+        <a:font script="Knda" typeface="Tunga"/>
+        <a:font script="Guru" typeface="Raavi"/>
+        <a:font script="Cans" typeface="Euphemia"/>
+        <a:font script="Cher" typeface="Plantagenet Cherokee"/>
+        <a:font script="Yiii" typeface="Microsoft Yi Baiti"/>
+        <a:font script="Tibt" typeface="Microsoft Himalaya"/>
+        <a:font script="Thaa" typeface="MV Boli"/>
+        <a:font script="Deva" typeface="Mangal"/>
+        <a:font script="Telu" typeface="Gautami"/>
+        <a:font script="Taml" typeface="Latha"/>
+        <a:font script="Syrc" typeface="Estrangelo Edessa"/>
+        <a:font script="Orya" typeface="Kalinga"/>
+        <a:font script="Mlym" typeface="Kartika"/>
+        <a:font script="Laoo" typeface="DokChampa"/>
+        <a:font script="Sinh" typeface="Iskoola Pota"/>
+        <a:font script="Mong" typeface="Mongolian Baiti"/>
+        <a:font script="Viet" typeface="Times New Roman"/>
+        <a:font script="Uigh" typeface="Microsoft Uighur"/>
+        <a:font script="Geor" typeface="Sylfaen"/>
+        <a:font script="Armn" typeface="Arial"/>
+        <a:font script="Bugi" typeface="Leelawadee UI"/>
+        <a:font script="Bopo" typeface="Microsoft JhengHei"/>
+        <a:font script="Java" typeface="Javanese Text"/>
+        <a:font script="Lisu" typeface="Segoe UI"/>
+        <a:font script="Mymr" typeface="Myanmar Text"/>
+        <a:font script="Nkoo" typeface="Ebrima"/>
+        <a:font script="Olck" typeface="Nirmala UI"/>
+        <a:font script="Osma" typeface="Ebrima"/>
+        <a:font script="Phag" typeface="Phagspa"/>
+        <a:font script="Syrn" typeface="Estrangelo Edessa"/>
+        <a:font script="Syrj" typeface="Estrangelo Edessa"/>
+        <a:font script="Syre" typeface="Estrangelo Edessa"/>
+        <a:font script="Sora" typeface="Nirmala UI"/>
+        <a:font script="Tale" typeface="Microsoft Tai Le"/>
+        <a:font script="Talu" typeface="Microsoft New Tai Lue"/>
+        <a:font script="Tfng" typeface="Ebrima"/>
+      </a:majorFont>
+      <a:minorFont>
+        <a:latin typeface="Calibri" panose="020F0502020204030204"/>
+        <a:ea typeface=""/>
+        <a:cs typeface=""/>
+        <a:font script="Jpan" typeface="游ゴシック"/>
+        <a:font script="Hang" typeface="맑은 고딕"/>
+        <a:font script="Hans" typeface="等线"/>
+        <a:font script="Hant" typeface="新細明體"/>
+        <a:font script="Arab" typeface="Arial"/>
+        <a:font script="Hebr" typeface="Arial"/>
+        <a:font script="Thai" typeface="Cordia New"/>
+        <a:font script="Ethi" typeface="Nyala"/>
+        <a:font script="Beng" typeface="Vrinda"/>
+        <a:font script="Gujr" typeface="Shruti"/>
+        <a:font script="Khmr" typeface="DaunPenh"/>
+        <a:font script="Knda" typeface="Tunga"/>
+        <a:font script="Guru" typeface="Raavi"/>
+        <a:font script="Cans" typeface="Euphemia"/>
+        <a:font script="Cher" typeface="Plantagenet Cherokee"/>
+        <a:font script="Yiii" typeface="Microsoft Yi Baiti"/>
+        <a:font script="Tibt" typeface="Microsoft Himalaya"/>
+        <a:font script="Thaa" typeface="MV Boli"/>
+        <a:font script="Deva" typeface="Mangal"/>
+        <a:font script="Telu" typeface="Gautami"/>
+        <a:font script="Taml" typeface="Latha"/>
+        <a:font script="Syrc" typeface="Estrangelo Edessa"/>
+        <a:font script="Orya" typeface="Kalinga"/>
+        <a:font script="Mlym" typeface="Kartika"/>
+        <a:font script="Laoo" typeface="DokChampa"/>
+        <a:font script="Sinh" typeface="Iskoola Pota"/>
+        <a:font script="Mong" typeface="Mongolian Baiti"/>
+        <a:font script="Viet" typeface="Arial"/>
+        <a:font script="Uigh" typeface="Microsoft Uighur"/>
+        <a:font script="Geor" typeface="Sylfaen"/>
+        <a:font script="Armn" typeface="Arial"/>
+        <a:font script="Bugi" typeface="Leelawadee UI"/>
+        <a:font script="Bopo" typeface="Microsoft JhengHei"/>
+        <a:font script="Java" typeface="Javanese Text"/>
+        <a:font script="Lisu" typeface="Segoe UI"/>
+        <a:font script="Mymr" typeface="Myanmar Text"/>
+        <a:font script="Nkoo" typeface="Ebrima"/>
+        <a:font script="Olck" typeface="Nirmala UI"/>
+        <a:font script="Osma" typeface="Ebrima"/>
+        <a:font script="Phag" typeface="Phagspa"/>
+        <a:font script="Syrn" typeface="Estrangelo Edessa"/>
+        <a:font script="Syrj" typeface="Estrangelo Edessa"/>
+        <a:font script="Syre" typeface="Estrangelo Edessa"/>
+        <a:font script="Sora" typeface="Nirmala UI"/>
+        <a:font script="Tale" typeface="Microsoft Tai Le"/>
+        <a:font script="Talu" typeface="Microsoft New Tai Lue"/>
+        <a:font script="Tfng" typeface="Ebrima"/>
+      </a:minorFont>
+    </a:fontScheme>
+    <a:fmtScheme name="Office">
+      <a:fillStyleLst>
+        <a:solidFill>
+          <a:schemeClr val="phClr"/>
+        </a:solidFill>
+        <a:gradFill rotWithShape="1">
+          <a:gsLst>
+            <a:gs pos="0">
+              <a:schemeClr val="phClr">
+                <a:lumMod val="110000"/>
+                <a:satMod val="105000"/>
+                <a:tint val="67000"/>
+              </a:schemeClr>
+            </a:gs>
+            <a:gs pos="50000">
+              <a:schemeClr val="phClr">
+                <a:lumMod val="105000"/>
+                <a:satMod val="103000"/>
+                <a:tint val="73000"/>
+              </a:schemeClr>
+            </a:gs>
+            <a:gs pos="100000">
+              <a:schemeClr val="phClr">
+                <a:lumMod val="105000"/>
+                <a:satMod val="109000"/>
+                <a:tint val="81000"/>
+              </a:schemeClr>
+            </a:gs>
+          </a:gsLst>
+          <a:lin ang="5400000" scaled="0"/>
+        </a:gradFill>
+        <a:gradFill rotWithShape="1">
+          <a:gsLst>
+            <a:gs pos="0">
+              <a:schemeClr val="phClr">
+                <a:satMod val="103000"/>
+                <a:lumMod val="102000"/>
+                <a:tint val="94000"/>
+              </a:schemeClr>
+            </a:gs>
+            <a:gs pos="50000">
+              <a:schemeClr val="phClr">
+                <a:satMod val="110000"/>
+                <a:lumMod val="100000"/>
+                <a:shade val="100000"/>
+              </a:schemeClr>
+            </a:gs>
+            <a:gs pos="100000">
+              <a:schemeClr val="phClr">
+                <a:lumMod val="99000"/>
+                <a:satMod val="120000"/>
+                <a:shade val="78000"/>
+              </a:schemeClr>
+            </a:gs>
+          </a:gsLst>
+          <a:lin ang="5400000" scaled="0"/>
+        </a:gradFill>
+      </a:fillStyleLst>
+      <a:lnStyleLst>
+        <a:ln w="6350" cap="flat" cmpd="sng" algn="ctr">
+          <a:solidFill>
+            <a:schemeClr val="phClr"/>
+          </a:solidFill>
+          <a:prstDash val="solid"/>
+          <a:miter lim="800000"/>
+        </a:ln>
+        <a:ln w="12700" cap="flat" cmpd="sng" algn="ctr">
+          <a:solidFill>
+            <a:schemeClr val="phClr"/>
+          </a:solidFill>
+          <a:prstDash val="solid"/>
+          <a:miter lim="800000"/>
+        </a:ln>
+        <a:ln w="19050" cap="flat" cmpd="sng" algn="ctr">
+          <a:solidFill>
+            <a:schemeClr val="phClr"/>
+          </a:solidFill>
+          <a:prstDash val="solid"/>
+          <a:miter lim="800000"/>
+        </a:ln>
+      </a:lnStyleLst>
+      <a:effectStyleLst>
+        <a:effectStyle>
+          <a:effectLst/>
+        </a:effectStyle>
+        <a:effectStyle>
+          <a:effectLst/>
+        </a:effectStyle>
+        <a:effectStyle>
+          <a:effectLst>
+            <a:outerShdw blurRad="57150" dist="19050" dir="5400000" algn="ctr" rotWithShape="0">
+              <a:srgbClr val="000000">
+                <a:alpha val="63000"/>
+              </a:srgbClr>
+            </a:outerShdw>
+          </a:effectLst>
+        </a:effectStyle>
+      </a:effectStyleLst>
+      <a:bgFillStyleLst>
+        <a:solidFill>
+          <a:schemeClr val="phClr"/>
+        </a:solidFill>
+        <a:solidFill>
+          <a:schemeClr val="phClr">
+            <a:tint val="95000"/>
+            <a:satMod val="170000"/>
+          </a:schemeClr>
+        </a:solidFill>
+        <a:gradFill rotWithShape="1">
+          <a:gsLst>
+            <a:gs pos="0">
+              <a:schemeClr val="phClr">
+                <a:tint val="93000"/>
+                <a:satMod val="150000"/>
+                <a:shade val="98000"/>
+                <a:lumMod val="102000"/>
+              </a:schemeClr>
+            </a:gs>
+            <a:gs pos="50000">
+              <a:schemeClr val="phClr">
+                <a:tint val="98000"/>
+                <a:satMod val="130000"/>
+                <a:shade val="90000"/>
+                <a:lumMod val="103000"/>
+              </a:schemeClr>
+            </a:gs>
+            <a:gs pos="100000">
+              <a:schemeClr val="phClr">
+                <a:shade val="63000"/>
+                <a:satMod val="120000"/>
+              </a:schemeClr>
+            </a:gs>
+          </a:gsLst>
+          <a:lin ang="5400000" scaled="0"/>
+        </a:gradFill>
+      </a:bgFillStyleLst>
+    </a:fmtScheme>
+  </a:themeElements>
+  <a:objectDefaults/>
+  <a:extraClrSchemeLst/>
+  <a:extLst>
+    <a:ext uri="{05A4C25C-085E-4340-85A3-A5531E510DB2}">
+      <thm15:themeFamily xmlns:thm15="http://schemas.microsoft.com/office/thememl/2012/main" name="Office Theme" id="{62F939B6-93AF-4DB8-9C6B-D6C7DFDC589F}" vid="{4A3C46E8-61CC-4603-A589-7422A47A8E4A}"/>
+    </a:ext>
+  </a:extLst>
+</a:theme>
 </file>
</xml_diff>